<commit_message>
docs: publish native editable figures and verified ICASSP draft
</commit_message>
<xml_diff>
--- a/figures/phaseset_architecture.pptx
+++ b/figures/phaseset_architecture.pptx
@@ -7,7 +7,7 @@
   <p:sldIdLst>
     <p:sldId id="256" r:id="rId7"/>
   </p:sldIdLst>
-  <p:sldSz cx="12191999" cy="4533243" type="screen4x3"/>
+  <p:sldSz cx="14630400" cy="5442509" type="screen4x3"/>
   <p:notesSz cx="6858000" cy="9144000"/>
   <p:defaultTextStyle>
     <a:defPPr>
@@ -3088,30 +3088,3719 @@
         <p:nvPr/>
       </p:nvGrpSpPr>
       <p:grpSpPr/>
-      <p:pic>
-        <p:nvPicPr>
-          <p:cNvPr id="2" name="Picture 1" descr="phaseset_architecture.png"/>
-          <p:cNvPicPr>
-            <a:picLocks noChangeAspect="1"/>
-          </p:cNvPicPr>
+      <p:sp>
+        <p:nvSpPr>
+          <p:cNvPr id="2" name="drawio-node-3"/>
+          <p:cNvSpPr/>
           <p:nvPr/>
-        </p:nvPicPr>
-        <p:blipFill>
-          <a:blip r:embed="rId2"/>
-          <a:stretch>
-            <a:fillRect/>
-          </a:stretch>
-        </p:blipFill>
-        <p:spPr>
-          <a:xfrm>
-            <a:off x="0" y="0"/>
-            <a:ext cx="12191999" cy="4533243"/>
+        </p:nvSpPr>
+        <p:spPr>
+          <a:xfrm>
+            <a:off x="234086" y="468173"/>
+            <a:ext cx="14162227" cy="2984602"/>
+          </a:xfrm>
+          <a:prstGeom prst="roundRect">
+            <a:avLst>
+              <a:gd name="adj" fmla="val 8000"/>
+            </a:avLst>
+          </a:prstGeom>
+          <a:solidFill>
+            <a:srgbClr val="F8FAFD"/>
+          </a:solidFill>
+          <a:ln w="11704">
+            <a:solidFill>
+              <a:srgbClr val="7792B8"/>
+            </a:solidFill>
+          </a:ln>
+        </p:spPr>
+        <p:style>
+          <a:lnRef idx="1">
+            <a:schemeClr val="accent1"/>
+          </a:lnRef>
+          <a:fillRef idx="3">
+            <a:schemeClr val="accent1"/>
+          </a:fillRef>
+          <a:effectRef idx="2">
+            <a:schemeClr val="accent1"/>
+          </a:effectRef>
+          <a:fontRef idx="minor">
+            <a:schemeClr val="lt1"/>
+          </a:fontRef>
+        </p:style>
+        <p:txBody>
+          <a:bodyPr rtlCol="0" anchor="ctr"/>
+          <a:lstStyle/>
+          <a:p>
+            <a:pPr algn="ctr"/>
+          </a:p>
+        </p:txBody>
+      </p:sp>
+      <p:sp>
+        <p:nvSpPr>
+          <p:cNvPr id="3" name="drawio-header-3"/>
+          <p:cNvSpPr txBox="1"/>
+          <p:nvPr/>
+        </p:nvSpPr>
+        <p:spPr>
+          <a:xfrm>
+            <a:off x="234086" y="468173"/>
+            <a:ext cx="14162227" cy="210678"/>
           </a:xfrm>
           <a:prstGeom prst="rect">
             <a:avLst/>
           </a:prstGeom>
-        </p:spPr>
-      </p:pic>
+          <a:noFill/>
+        </p:spPr>
+        <p:txBody>
+          <a:bodyPr wrap="square" lIns="17556" rIns="17556" tIns="5852" bIns="5852" anchor="ctr">
+            <a:spAutoFit/>
+          </a:bodyPr>
+          <a:lstStyle/>
+          <a:p>
+            <a:pPr algn="ctr">
+              <a:spcBef>
+                <a:spcPts val="0"/>
+              </a:spcBef>
+              <a:spcAft>
+                <a:spcPts val="0"/>
+              </a:spcAft>
+            </a:pPr>
+            <a:r>
+              <a:rPr sz="829" b="1">
+                <a:solidFill>
+                  <a:srgbClr val="000000"/>
+                </a:solidFill>
+                <a:latin typeface="Arial"/>
+              </a:rPr>
+              <a:t>Motion path</a:t>
+            </a:r>
+          </a:p>
+        </p:txBody>
+      </p:sp>
+      <p:cxnSp>
+        <p:nvCxnSpPr>
+          <p:cNvPr id="4" name="drawio-container-separator-3"/>
+          <p:cNvCxnSpPr/>
+          <p:nvPr/>
+        </p:nvCxnSpPr>
+        <p:spPr>
+          <a:xfrm>
+            <a:off x="234086" y="678851"/>
+            <a:ext cx="14162228" cy="0"/>
+          </a:xfrm>
+          <a:prstGeom prst="line">
+            <a:avLst/>
+          </a:prstGeom>
+          <a:ln w="11704">
+            <a:solidFill>
+              <a:srgbClr val="7792B8"/>
+            </a:solidFill>
+          </a:ln>
+        </p:spPr>
+        <p:style>
+          <a:lnRef idx="2">
+            <a:schemeClr val="accent1"/>
+          </a:lnRef>
+          <a:fillRef idx="0">
+            <a:schemeClr val="accent1"/>
+          </a:fillRef>
+          <a:effectRef idx="1">
+            <a:schemeClr val="accent1"/>
+          </a:effectRef>
+          <a:fontRef idx="minor">
+            <a:schemeClr val="tx1"/>
+          </a:fontRef>
+        </p:style>
+      </p:cxnSp>
+      <p:sp>
+        <p:nvSpPr>
+          <p:cNvPr id="5" name="drawio-node-4"/>
+          <p:cNvSpPr/>
+          <p:nvPr/>
+        </p:nvSpPr>
+        <p:spPr>
+          <a:xfrm>
+            <a:off x="234086" y="3628339"/>
+            <a:ext cx="14162227" cy="1404518"/>
+          </a:xfrm>
+          <a:prstGeom prst="roundRect">
+            <a:avLst>
+              <a:gd name="adj" fmla="val 8000"/>
+            </a:avLst>
+          </a:prstGeom>
+          <a:solidFill>
+            <a:srgbClr val="FCFAFF"/>
+          </a:solidFill>
+          <a:ln w="11704">
+            <a:solidFill>
+              <a:srgbClr val="9673A6"/>
+            </a:solidFill>
+          </a:ln>
+        </p:spPr>
+        <p:style>
+          <a:lnRef idx="1">
+            <a:schemeClr val="accent1"/>
+          </a:lnRef>
+          <a:fillRef idx="3">
+            <a:schemeClr val="accent1"/>
+          </a:fillRef>
+          <a:effectRef idx="2">
+            <a:schemeClr val="accent1"/>
+          </a:effectRef>
+          <a:fontRef idx="minor">
+            <a:schemeClr val="lt1"/>
+          </a:fontRef>
+        </p:style>
+        <p:txBody>
+          <a:bodyPr rtlCol="0" anchor="ctr"/>
+          <a:lstStyle/>
+          <a:p>
+            <a:pPr algn="ctr"/>
+          </a:p>
+        </p:txBody>
+      </p:sp>
+      <p:sp>
+        <p:nvSpPr>
+          <p:cNvPr id="6" name="drawio-header-4"/>
+          <p:cNvSpPr txBox="1"/>
+          <p:nvPr/>
+        </p:nvSpPr>
+        <p:spPr>
+          <a:xfrm>
+            <a:off x="234086" y="3628339"/>
+            <a:ext cx="14162227" cy="210678"/>
+          </a:xfrm>
+          <a:prstGeom prst="rect">
+            <a:avLst/>
+          </a:prstGeom>
+          <a:noFill/>
+        </p:spPr>
+        <p:txBody>
+          <a:bodyPr wrap="square" lIns="17556" rIns="17556" tIns="5852" bIns="5852" anchor="ctr">
+            <a:spAutoFit/>
+          </a:bodyPr>
+          <a:lstStyle/>
+          <a:p>
+            <a:pPr algn="ctr">
+              <a:spcBef>
+                <a:spcPts val="0"/>
+              </a:spcBef>
+              <a:spcAft>
+                <a:spcPts val="0"/>
+              </a:spcAft>
+            </a:pPr>
+            <a:r>
+              <a:rPr sz="829" b="1">
+                <a:solidFill>
+                  <a:srgbClr val="000000"/>
+                </a:solidFill>
+                <a:latin typeface="Arial"/>
+              </a:rPr>
+              <a:t>Language path and retrieval</a:t>
+            </a:r>
+          </a:p>
+        </p:txBody>
+      </p:sp>
+      <p:cxnSp>
+        <p:nvCxnSpPr>
+          <p:cNvPr id="7" name="drawio-container-separator-4"/>
+          <p:cNvCxnSpPr/>
+          <p:nvPr/>
+        </p:nvCxnSpPr>
+        <p:spPr>
+          <a:xfrm>
+            <a:off x="234086" y="3839017"/>
+            <a:ext cx="14162228" cy="0"/>
+          </a:xfrm>
+          <a:prstGeom prst="line">
+            <a:avLst/>
+          </a:prstGeom>
+          <a:ln w="11704">
+            <a:solidFill>
+              <a:srgbClr val="9673A6"/>
+            </a:solidFill>
+          </a:ln>
+        </p:spPr>
+        <p:style>
+          <a:lnRef idx="2">
+            <a:schemeClr val="accent1"/>
+          </a:lnRef>
+          <a:fillRef idx="0">
+            <a:schemeClr val="accent1"/>
+          </a:fillRef>
+          <a:effectRef idx="1">
+            <a:schemeClr val="accent1"/>
+          </a:effectRef>
+          <a:fontRef idx="minor">
+            <a:schemeClr val="tx1"/>
+          </a:fontRef>
+        </p:style>
+      </p:cxnSp>
+      <p:cxnSp>
+        <p:nvCxnSpPr>
+          <p:cNvPr id="8" name="drawio-edge-30-segment-0"/>
+          <p:cNvCxnSpPr/>
+          <p:nvPr/>
+        </p:nvCxnSpPr>
+        <p:spPr>
+          <a:xfrm>
+            <a:off x="1697126" y="1316736"/>
+            <a:ext cx="351130" cy="0"/>
+          </a:xfrm>
+          <a:prstGeom prst="line">
+            <a:avLst/>
+          </a:prstGeom>
+          <a:ln w="11704">
+            <a:solidFill>
+              <a:srgbClr val="506784"/>
+            </a:solidFill>
+            <a:tailEnd type="triangle"/>
+          </a:ln>
+        </p:spPr>
+        <p:style>
+          <a:lnRef idx="2">
+            <a:schemeClr val="accent1"/>
+          </a:lnRef>
+          <a:fillRef idx="0">
+            <a:schemeClr val="accent1"/>
+          </a:fillRef>
+          <a:effectRef idx="1">
+            <a:schemeClr val="accent1"/>
+          </a:effectRef>
+          <a:fontRef idx="minor">
+            <a:schemeClr val="tx1"/>
+          </a:fontRef>
+        </p:style>
+      </p:cxnSp>
+      <p:cxnSp>
+        <p:nvCxnSpPr>
+          <p:cNvPr id="9" name="drawio-edge-31-segment-0"/>
+          <p:cNvCxnSpPr/>
+          <p:nvPr/>
+        </p:nvCxnSpPr>
+        <p:spPr>
+          <a:xfrm>
+            <a:off x="3277210" y="1316736"/>
+            <a:ext cx="351129" cy="0"/>
+          </a:xfrm>
+          <a:prstGeom prst="line">
+            <a:avLst/>
+          </a:prstGeom>
+          <a:ln w="11704">
+            <a:solidFill>
+              <a:srgbClr val="506784"/>
+            </a:solidFill>
+            <a:tailEnd type="triangle"/>
+          </a:ln>
+        </p:spPr>
+        <p:style>
+          <a:lnRef idx="2">
+            <a:schemeClr val="accent1"/>
+          </a:lnRef>
+          <a:fillRef idx="0">
+            <a:schemeClr val="accent1"/>
+          </a:fillRef>
+          <a:effectRef idx="1">
+            <a:schemeClr val="accent1"/>
+          </a:effectRef>
+          <a:fontRef idx="minor">
+            <a:schemeClr val="tx1"/>
+          </a:fontRef>
+        </p:style>
+      </p:cxnSp>
+      <p:cxnSp>
+        <p:nvCxnSpPr>
+          <p:cNvPr id="10" name="drawio-edge-32-segment-0"/>
+          <p:cNvCxnSpPr/>
+          <p:nvPr/>
+        </p:nvCxnSpPr>
+        <p:spPr>
+          <a:xfrm>
+            <a:off x="4974336" y="1316736"/>
+            <a:ext cx="351130" cy="0"/>
+          </a:xfrm>
+          <a:prstGeom prst="line">
+            <a:avLst/>
+          </a:prstGeom>
+          <a:ln w="11704">
+            <a:solidFill>
+              <a:srgbClr val="506784"/>
+            </a:solidFill>
+            <a:tailEnd type="triangle"/>
+          </a:ln>
+        </p:spPr>
+        <p:style>
+          <a:lnRef idx="2">
+            <a:schemeClr val="accent1"/>
+          </a:lnRef>
+          <a:fillRef idx="0">
+            <a:schemeClr val="accent1"/>
+          </a:fillRef>
+          <a:effectRef idx="1">
+            <a:schemeClr val="accent1"/>
+          </a:effectRef>
+          <a:fontRef idx="minor">
+            <a:schemeClr val="tx1"/>
+          </a:fontRef>
+        </p:style>
+      </p:cxnSp>
+      <p:cxnSp>
+        <p:nvCxnSpPr>
+          <p:cNvPr id="11" name="drawio-edge-33-segment-0"/>
+          <p:cNvCxnSpPr/>
+          <p:nvPr/>
+        </p:nvCxnSpPr>
+        <p:spPr>
+          <a:xfrm>
+            <a:off x="6788506" y="1316736"/>
+            <a:ext cx="351129" cy="0"/>
+          </a:xfrm>
+          <a:prstGeom prst="line">
+            <a:avLst/>
+          </a:prstGeom>
+          <a:ln w="11704">
+            <a:solidFill>
+              <a:srgbClr val="506784"/>
+            </a:solidFill>
+            <a:tailEnd type="triangle"/>
+          </a:ln>
+        </p:spPr>
+        <p:style>
+          <a:lnRef idx="2">
+            <a:schemeClr val="accent1"/>
+          </a:lnRef>
+          <a:fillRef idx="0">
+            <a:schemeClr val="accent1"/>
+          </a:fillRef>
+          <a:effectRef idx="1">
+            <a:schemeClr val="accent1"/>
+          </a:effectRef>
+          <a:fontRef idx="minor">
+            <a:schemeClr val="tx1"/>
+          </a:fontRef>
+        </p:style>
+      </p:cxnSp>
+      <p:cxnSp>
+        <p:nvCxnSpPr>
+          <p:cNvPr id="12" name="drawio-edge-34-segment-0"/>
+          <p:cNvCxnSpPr/>
+          <p:nvPr/>
+        </p:nvCxnSpPr>
+        <p:spPr>
+          <a:xfrm>
+            <a:off x="8368589" y="1220175"/>
+            <a:ext cx="175565" cy="0"/>
+          </a:xfrm>
+          <a:prstGeom prst="line">
+            <a:avLst/>
+          </a:prstGeom>
+          <a:ln w="11704">
+            <a:solidFill>
+              <a:srgbClr val="506784"/>
+            </a:solidFill>
+          </a:ln>
+        </p:spPr>
+        <p:style>
+          <a:lnRef idx="2">
+            <a:schemeClr val="accent1"/>
+          </a:lnRef>
+          <a:fillRef idx="0">
+            <a:schemeClr val="accent1"/>
+          </a:fillRef>
+          <a:effectRef idx="1">
+            <a:schemeClr val="accent1"/>
+          </a:effectRef>
+          <a:fontRef idx="minor">
+            <a:schemeClr val="tx1"/>
+          </a:fontRef>
+        </p:style>
+      </p:cxnSp>
+      <p:cxnSp>
+        <p:nvCxnSpPr>
+          <p:cNvPr id="13" name="drawio-edge-34-segment-1"/>
+          <p:cNvCxnSpPr/>
+          <p:nvPr/>
+        </p:nvCxnSpPr>
+        <p:spPr>
+          <a:xfrm flipV="1">
+            <a:off x="8544154" y="1053389"/>
+            <a:ext cx="0" cy="166786"/>
+          </a:xfrm>
+          <a:prstGeom prst="line">
+            <a:avLst/>
+          </a:prstGeom>
+          <a:ln w="11704">
+            <a:solidFill>
+              <a:srgbClr val="506784"/>
+            </a:solidFill>
+          </a:ln>
+        </p:spPr>
+        <p:style>
+          <a:lnRef idx="2">
+            <a:schemeClr val="accent1"/>
+          </a:lnRef>
+          <a:fillRef idx="0">
+            <a:schemeClr val="accent1"/>
+          </a:fillRef>
+          <a:effectRef idx="1">
+            <a:schemeClr val="accent1"/>
+          </a:effectRef>
+          <a:fontRef idx="minor">
+            <a:schemeClr val="tx1"/>
+          </a:fontRef>
+        </p:style>
+      </p:cxnSp>
+      <p:cxnSp>
+        <p:nvCxnSpPr>
+          <p:cNvPr id="14" name="drawio-edge-34-segment-2"/>
+          <p:cNvCxnSpPr/>
+          <p:nvPr/>
+        </p:nvCxnSpPr>
+        <p:spPr>
+          <a:xfrm>
+            <a:off x="8544154" y="1053389"/>
+            <a:ext cx="175564" cy="0"/>
+          </a:xfrm>
+          <a:prstGeom prst="line">
+            <a:avLst/>
+          </a:prstGeom>
+          <a:ln w="11704">
+            <a:solidFill>
+              <a:srgbClr val="506784"/>
+            </a:solidFill>
+            <a:tailEnd type="triangle"/>
+          </a:ln>
+        </p:spPr>
+        <p:style>
+          <a:lnRef idx="2">
+            <a:schemeClr val="accent1"/>
+          </a:lnRef>
+          <a:fillRef idx="0">
+            <a:schemeClr val="accent1"/>
+          </a:fillRef>
+          <a:effectRef idx="1">
+            <a:schemeClr val="accent1"/>
+          </a:effectRef>
+          <a:fontRef idx="minor">
+            <a:schemeClr val="tx1"/>
+          </a:fontRef>
+        </p:style>
+      </p:cxnSp>
+      <p:cxnSp>
+        <p:nvCxnSpPr>
+          <p:cNvPr id="15" name="drawio-edge-35-segment-0"/>
+          <p:cNvCxnSpPr/>
+          <p:nvPr/>
+        </p:nvCxnSpPr>
+        <p:spPr>
+          <a:xfrm>
+            <a:off x="8368589" y="1445484"/>
+            <a:ext cx="175565" cy="0"/>
+          </a:xfrm>
+          <a:prstGeom prst="line">
+            <a:avLst/>
+          </a:prstGeom>
+          <a:ln w="11704">
+            <a:solidFill>
+              <a:srgbClr val="506784"/>
+            </a:solidFill>
+          </a:ln>
+        </p:spPr>
+        <p:style>
+          <a:lnRef idx="2">
+            <a:schemeClr val="accent1"/>
+          </a:lnRef>
+          <a:fillRef idx="0">
+            <a:schemeClr val="accent1"/>
+          </a:fillRef>
+          <a:effectRef idx="1">
+            <a:schemeClr val="accent1"/>
+          </a:effectRef>
+          <a:fontRef idx="minor">
+            <a:schemeClr val="tx1"/>
+          </a:fontRef>
+        </p:style>
+      </p:cxnSp>
+      <p:cxnSp>
+        <p:nvCxnSpPr>
+          <p:cNvPr id="16" name="drawio-edge-35-segment-1"/>
+          <p:cNvCxnSpPr/>
+          <p:nvPr/>
+        </p:nvCxnSpPr>
+        <p:spPr>
+          <a:xfrm>
+            <a:off x="8544154" y="1445484"/>
+            <a:ext cx="0" cy="544250"/>
+          </a:xfrm>
+          <a:prstGeom prst="line">
+            <a:avLst/>
+          </a:prstGeom>
+          <a:ln w="11704">
+            <a:solidFill>
+              <a:srgbClr val="506784"/>
+            </a:solidFill>
+          </a:ln>
+        </p:spPr>
+        <p:style>
+          <a:lnRef idx="2">
+            <a:schemeClr val="accent1"/>
+          </a:lnRef>
+          <a:fillRef idx="0">
+            <a:schemeClr val="accent1"/>
+          </a:fillRef>
+          <a:effectRef idx="1">
+            <a:schemeClr val="accent1"/>
+          </a:effectRef>
+          <a:fontRef idx="minor">
+            <a:schemeClr val="tx1"/>
+          </a:fontRef>
+        </p:style>
+      </p:cxnSp>
+      <p:cxnSp>
+        <p:nvCxnSpPr>
+          <p:cNvPr id="17" name="drawio-edge-35-segment-2"/>
+          <p:cNvCxnSpPr/>
+          <p:nvPr/>
+        </p:nvCxnSpPr>
+        <p:spPr>
+          <a:xfrm>
+            <a:off x="8544154" y="1989734"/>
+            <a:ext cx="175564" cy="0"/>
+          </a:xfrm>
+          <a:prstGeom prst="line">
+            <a:avLst/>
+          </a:prstGeom>
+          <a:ln w="11704">
+            <a:solidFill>
+              <a:srgbClr val="506784"/>
+            </a:solidFill>
+            <a:tailEnd type="triangle"/>
+          </a:ln>
+        </p:spPr>
+        <p:style>
+          <a:lnRef idx="2">
+            <a:schemeClr val="accent1"/>
+          </a:lnRef>
+          <a:fillRef idx="0">
+            <a:schemeClr val="accent1"/>
+          </a:fillRef>
+          <a:effectRef idx="1">
+            <a:schemeClr val="accent1"/>
+          </a:effectRef>
+          <a:fontRef idx="minor">
+            <a:schemeClr val="tx1"/>
+          </a:fontRef>
+        </p:style>
+      </p:cxnSp>
+      <p:cxnSp>
+        <p:nvCxnSpPr>
+          <p:cNvPr id="18" name="drawio-edge-36-segment-0"/>
+          <p:cNvCxnSpPr/>
+          <p:nvPr/>
+        </p:nvCxnSpPr>
+        <p:spPr>
+          <a:xfrm>
+            <a:off x="10065715" y="1053389"/>
+            <a:ext cx="351130" cy="0"/>
+          </a:xfrm>
+          <a:prstGeom prst="line">
+            <a:avLst/>
+          </a:prstGeom>
+          <a:ln w="11704">
+            <a:solidFill>
+              <a:srgbClr val="506784"/>
+            </a:solidFill>
+            <a:tailEnd type="triangle"/>
+          </a:ln>
+        </p:spPr>
+        <p:style>
+          <a:lnRef idx="2">
+            <a:schemeClr val="accent1"/>
+          </a:lnRef>
+          <a:fillRef idx="0">
+            <a:schemeClr val="accent1"/>
+          </a:fillRef>
+          <a:effectRef idx="1">
+            <a:schemeClr val="accent1"/>
+          </a:effectRef>
+          <a:fontRef idx="minor">
+            <a:schemeClr val="tx1"/>
+          </a:fontRef>
+        </p:style>
+      </p:cxnSp>
+      <p:cxnSp>
+        <p:nvCxnSpPr>
+          <p:cNvPr id="19" name="drawio-edge-37-segment-0"/>
+          <p:cNvCxnSpPr/>
+          <p:nvPr/>
+        </p:nvCxnSpPr>
+        <p:spPr>
+          <a:xfrm>
+            <a:off x="10065715" y="1989734"/>
+            <a:ext cx="351130" cy="0"/>
+          </a:xfrm>
+          <a:prstGeom prst="line">
+            <a:avLst/>
+          </a:prstGeom>
+          <a:ln w="11704">
+            <a:solidFill>
+              <a:srgbClr val="506784"/>
+            </a:solidFill>
+            <a:tailEnd type="triangle"/>
+          </a:ln>
+        </p:spPr>
+        <p:style>
+          <a:lnRef idx="2">
+            <a:schemeClr val="accent1"/>
+          </a:lnRef>
+          <a:fillRef idx="0">
+            <a:schemeClr val="accent1"/>
+          </a:fillRef>
+          <a:effectRef idx="1">
+            <a:schemeClr val="accent1"/>
+          </a:effectRef>
+          <a:fontRef idx="minor">
+            <a:schemeClr val="tx1"/>
+          </a:fontRef>
+        </p:style>
+      </p:cxnSp>
+      <p:cxnSp>
+        <p:nvCxnSpPr>
+          <p:cNvPr id="20" name="drawio-edge-38-segment-0"/>
+          <p:cNvCxnSpPr/>
+          <p:nvPr/>
+        </p:nvCxnSpPr>
+        <p:spPr>
+          <a:xfrm>
+            <a:off x="11704320" y="1053389"/>
+            <a:ext cx="234086" cy="0"/>
+          </a:xfrm>
+          <a:prstGeom prst="line">
+            <a:avLst/>
+          </a:prstGeom>
+          <a:ln w="11704">
+            <a:solidFill>
+              <a:srgbClr val="506784"/>
+            </a:solidFill>
+          </a:ln>
+        </p:spPr>
+        <p:style>
+          <a:lnRef idx="2">
+            <a:schemeClr val="accent1"/>
+          </a:lnRef>
+          <a:fillRef idx="0">
+            <a:schemeClr val="accent1"/>
+          </a:fillRef>
+          <a:effectRef idx="1">
+            <a:schemeClr val="accent1"/>
+          </a:effectRef>
+          <a:fontRef idx="minor">
+            <a:schemeClr val="tx1"/>
+          </a:fontRef>
+        </p:style>
+      </p:cxnSp>
+      <p:cxnSp>
+        <p:nvCxnSpPr>
+          <p:cNvPr id="21" name="drawio-edge-38-segment-1"/>
+          <p:cNvCxnSpPr/>
+          <p:nvPr/>
+        </p:nvCxnSpPr>
+        <p:spPr>
+          <a:xfrm>
+            <a:off x="11938406" y="1053389"/>
+            <a:ext cx="0" cy="251643"/>
+          </a:xfrm>
+          <a:prstGeom prst="line">
+            <a:avLst/>
+          </a:prstGeom>
+          <a:ln w="11704">
+            <a:solidFill>
+              <a:srgbClr val="506784"/>
+            </a:solidFill>
+          </a:ln>
+        </p:spPr>
+        <p:style>
+          <a:lnRef idx="2">
+            <a:schemeClr val="accent1"/>
+          </a:lnRef>
+          <a:fillRef idx="0">
+            <a:schemeClr val="accent1"/>
+          </a:fillRef>
+          <a:effectRef idx="1">
+            <a:schemeClr val="accent1"/>
+          </a:effectRef>
+          <a:fontRef idx="minor">
+            <a:schemeClr val="tx1"/>
+          </a:fontRef>
+        </p:style>
+      </p:cxnSp>
+      <p:cxnSp>
+        <p:nvCxnSpPr>
+          <p:cNvPr id="22" name="drawio-edge-38-segment-2"/>
+          <p:cNvCxnSpPr/>
+          <p:nvPr/>
+        </p:nvCxnSpPr>
+        <p:spPr>
+          <a:xfrm>
+            <a:off x="11938406" y="1305032"/>
+            <a:ext cx="234087" cy="0"/>
+          </a:xfrm>
+          <a:prstGeom prst="line">
+            <a:avLst/>
+          </a:prstGeom>
+          <a:ln w="11704">
+            <a:solidFill>
+              <a:srgbClr val="506784"/>
+            </a:solidFill>
+            <a:tailEnd type="triangle"/>
+          </a:ln>
+        </p:spPr>
+        <p:style>
+          <a:lnRef idx="2">
+            <a:schemeClr val="accent1"/>
+          </a:lnRef>
+          <a:fillRef idx="0">
+            <a:schemeClr val="accent1"/>
+          </a:fillRef>
+          <a:effectRef idx="1">
+            <a:schemeClr val="accent1"/>
+          </a:effectRef>
+          <a:fontRef idx="minor">
+            <a:schemeClr val="tx1"/>
+          </a:fontRef>
+        </p:style>
+      </p:cxnSp>
+      <p:cxnSp>
+        <p:nvCxnSpPr>
+          <p:cNvPr id="23" name="drawio-edge-39-segment-0"/>
+          <p:cNvCxnSpPr/>
+          <p:nvPr/>
+        </p:nvCxnSpPr>
+        <p:spPr>
+          <a:xfrm>
+            <a:off x="11821363" y="1989734"/>
+            <a:ext cx="175565" cy="0"/>
+          </a:xfrm>
+          <a:prstGeom prst="line">
+            <a:avLst/>
+          </a:prstGeom>
+          <a:ln w="11704">
+            <a:solidFill>
+              <a:srgbClr val="506784"/>
+            </a:solidFill>
+          </a:ln>
+        </p:spPr>
+        <p:style>
+          <a:lnRef idx="2">
+            <a:schemeClr val="accent1"/>
+          </a:lnRef>
+          <a:fillRef idx="0">
+            <a:schemeClr val="accent1"/>
+          </a:fillRef>
+          <a:effectRef idx="1">
+            <a:schemeClr val="accent1"/>
+          </a:effectRef>
+          <a:fontRef idx="minor">
+            <a:schemeClr val="tx1"/>
+          </a:fontRef>
+        </p:style>
+      </p:cxnSp>
+      <p:cxnSp>
+        <p:nvCxnSpPr>
+          <p:cNvPr id="24" name="drawio-edge-39-segment-1"/>
+          <p:cNvCxnSpPr/>
+          <p:nvPr/>
+        </p:nvCxnSpPr>
+        <p:spPr>
+          <a:xfrm flipV="1">
+            <a:off x="11996928" y="1594714"/>
+            <a:ext cx="0" cy="395020"/>
+          </a:xfrm>
+          <a:prstGeom prst="line">
+            <a:avLst/>
+          </a:prstGeom>
+          <a:ln w="11704">
+            <a:solidFill>
+              <a:srgbClr val="506784"/>
+            </a:solidFill>
+          </a:ln>
+        </p:spPr>
+        <p:style>
+          <a:lnRef idx="2">
+            <a:schemeClr val="accent1"/>
+          </a:lnRef>
+          <a:fillRef idx="0">
+            <a:schemeClr val="accent1"/>
+          </a:fillRef>
+          <a:effectRef idx="1">
+            <a:schemeClr val="accent1"/>
+          </a:effectRef>
+          <a:fontRef idx="minor">
+            <a:schemeClr val="tx1"/>
+          </a:fontRef>
+        </p:style>
+      </p:cxnSp>
+      <p:cxnSp>
+        <p:nvCxnSpPr>
+          <p:cNvPr id="25" name="drawio-edge-39-segment-2"/>
+          <p:cNvCxnSpPr/>
+          <p:nvPr/>
+        </p:nvCxnSpPr>
+        <p:spPr>
+          <a:xfrm>
+            <a:off x="11996928" y="1594714"/>
+            <a:ext cx="175565" cy="0"/>
+          </a:xfrm>
+          <a:prstGeom prst="line">
+            <a:avLst/>
+          </a:prstGeom>
+          <a:ln w="11704">
+            <a:solidFill>
+              <a:srgbClr val="506784"/>
+            </a:solidFill>
+            <a:tailEnd type="triangle"/>
+          </a:ln>
+        </p:spPr>
+        <p:style>
+          <a:lnRef idx="2">
+            <a:schemeClr val="accent1"/>
+          </a:lnRef>
+          <a:fillRef idx="0">
+            <a:schemeClr val="accent1"/>
+          </a:fillRef>
+          <a:effectRef idx="1">
+            <a:schemeClr val="accent1"/>
+          </a:effectRef>
+          <a:fontRef idx="minor">
+            <a:schemeClr val="tx1"/>
+          </a:fontRef>
+        </p:style>
+      </p:cxnSp>
+      <p:cxnSp>
+        <p:nvCxnSpPr>
+          <p:cNvPr id="26" name="drawio-edge-40-segment-0"/>
+          <p:cNvCxnSpPr/>
+          <p:nvPr/>
+        </p:nvCxnSpPr>
+        <p:spPr>
+          <a:xfrm>
+            <a:off x="12874752" y="1755648"/>
+            <a:ext cx="0" cy="643738"/>
+          </a:xfrm>
+          <a:prstGeom prst="line">
+            <a:avLst/>
+          </a:prstGeom>
+          <a:ln w="11704">
+            <a:solidFill>
+              <a:srgbClr val="506784"/>
+            </a:solidFill>
+            <a:tailEnd type="triangle"/>
+          </a:ln>
+        </p:spPr>
+        <p:style>
+          <a:lnRef idx="2">
+            <a:schemeClr val="accent1"/>
+          </a:lnRef>
+          <a:fillRef idx="0">
+            <a:schemeClr val="accent1"/>
+          </a:fillRef>
+          <a:effectRef idx="1">
+            <a:schemeClr val="accent1"/>
+          </a:effectRef>
+          <a:fontRef idx="minor">
+            <a:schemeClr val="tx1"/>
+          </a:fontRef>
+        </p:style>
+      </p:cxnSp>
+      <p:cxnSp>
+        <p:nvCxnSpPr>
+          <p:cNvPr id="27" name="drawio-edge-55-segment-0"/>
+          <p:cNvCxnSpPr/>
+          <p:nvPr/>
+        </p:nvCxnSpPr>
+        <p:spPr>
+          <a:xfrm>
+            <a:off x="3277210" y="4359859"/>
+            <a:ext cx="760780" cy="0"/>
+          </a:xfrm>
+          <a:prstGeom prst="line">
+            <a:avLst/>
+          </a:prstGeom>
+          <a:ln w="11704">
+            <a:solidFill>
+              <a:srgbClr val="806491"/>
+            </a:solidFill>
+            <a:tailEnd type="triangle"/>
+          </a:ln>
+        </p:spPr>
+        <p:style>
+          <a:lnRef idx="2">
+            <a:schemeClr val="accent1"/>
+          </a:lnRef>
+          <a:fillRef idx="0">
+            <a:schemeClr val="accent1"/>
+          </a:fillRef>
+          <a:effectRef idx="1">
+            <a:schemeClr val="accent1"/>
+          </a:effectRef>
+          <a:fontRef idx="minor">
+            <a:schemeClr val="tx1"/>
+          </a:fontRef>
+        </p:style>
+      </p:cxnSp>
+      <p:cxnSp>
+        <p:nvCxnSpPr>
+          <p:cNvPr id="28" name="drawio-edge-56-segment-0"/>
+          <p:cNvCxnSpPr/>
+          <p:nvPr/>
+        </p:nvCxnSpPr>
+        <p:spPr>
+          <a:xfrm>
+            <a:off x="5325466" y="4359859"/>
+            <a:ext cx="760780" cy="0"/>
+          </a:xfrm>
+          <a:prstGeom prst="line">
+            <a:avLst/>
+          </a:prstGeom>
+          <a:ln w="11704">
+            <a:solidFill>
+              <a:srgbClr val="806491"/>
+            </a:solidFill>
+            <a:tailEnd type="triangle"/>
+          </a:ln>
+        </p:spPr>
+        <p:style>
+          <a:lnRef idx="2">
+            <a:schemeClr val="accent1"/>
+          </a:lnRef>
+          <a:fillRef idx="0">
+            <a:schemeClr val="accent1"/>
+          </a:fillRef>
+          <a:effectRef idx="1">
+            <a:schemeClr val="accent1"/>
+          </a:effectRef>
+          <a:fontRef idx="minor">
+            <a:schemeClr val="tx1"/>
+          </a:fontRef>
+        </p:style>
+      </p:cxnSp>
+      <p:cxnSp>
+        <p:nvCxnSpPr>
+          <p:cNvPr id="29" name="drawio-edge-57-segment-0"/>
+          <p:cNvCxnSpPr/>
+          <p:nvPr/>
+        </p:nvCxnSpPr>
+        <p:spPr>
+          <a:xfrm>
+            <a:off x="7490765" y="4359859"/>
+            <a:ext cx="760781" cy="0"/>
+          </a:xfrm>
+          <a:prstGeom prst="line">
+            <a:avLst/>
+          </a:prstGeom>
+          <a:ln w="11704">
+            <a:solidFill>
+              <a:srgbClr val="806491"/>
+            </a:solidFill>
+            <a:tailEnd type="triangle"/>
+          </a:ln>
+        </p:spPr>
+        <p:style>
+          <a:lnRef idx="2">
+            <a:schemeClr val="accent1"/>
+          </a:lnRef>
+          <a:fillRef idx="0">
+            <a:schemeClr val="accent1"/>
+          </a:fillRef>
+          <a:effectRef idx="1">
+            <a:schemeClr val="accent1"/>
+          </a:effectRef>
+          <a:fontRef idx="minor">
+            <a:schemeClr val="tx1"/>
+          </a:fontRef>
+        </p:style>
+      </p:cxnSp>
+      <p:cxnSp>
+        <p:nvCxnSpPr>
+          <p:cNvPr id="30" name="drawio-edge-58-segment-0"/>
+          <p:cNvCxnSpPr/>
+          <p:nvPr/>
+        </p:nvCxnSpPr>
+        <p:spPr>
+          <a:xfrm>
+            <a:off x="9597542" y="4359859"/>
+            <a:ext cx="731520" cy="0"/>
+          </a:xfrm>
+          <a:prstGeom prst="line">
+            <a:avLst/>
+          </a:prstGeom>
+          <a:ln w="11704">
+            <a:solidFill>
+              <a:srgbClr val="806491"/>
+            </a:solidFill>
+          </a:ln>
+        </p:spPr>
+        <p:style>
+          <a:lnRef idx="2">
+            <a:schemeClr val="accent1"/>
+          </a:lnRef>
+          <a:fillRef idx="0">
+            <a:schemeClr val="accent1"/>
+          </a:fillRef>
+          <a:effectRef idx="1">
+            <a:schemeClr val="accent1"/>
+          </a:effectRef>
+          <a:fontRef idx="minor">
+            <a:schemeClr val="tx1"/>
+          </a:fontRef>
+        </p:style>
+      </p:cxnSp>
+      <p:cxnSp>
+        <p:nvCxnSpPr>
+          <p:cNvPr id="31" name="drawio-edge-58-segment-1"/>
+          <p:cNvCxnSpPr/>
+          <p:nvPr/>
+        </p:nvCxnSpPr>
+        <p:spPr>
+          <a:xfrm>
+            <a:off x="10329062" y="4359859"/>
+            <a:ext cx="0" cy="96561"/>
+          </a:xfrm>
+          <a:prstGeom prst="line">
+            <a:avLst/>
+          </a:prstGeom>
+          <a:ln w="11704">
+            <a:solidFill>
+              <a:srgbClr val="806491"/>
+            </a:solidFill>
+          </a:ln>
+        </p:spPr>
+        <p:style>
+          <a:lnRef idx="2">
+            <a:schemeClr val="accent1"/>
+          </a:lnRef>
+          <a:fillRef idx="0">
+            <a:schemeClr val="accent1"/>
+          </a:fillRef>
+          <a:effectRef idx="1">
+            <a:schemeClr val="accent1"/>
+          </a:effectRef>
+          <a:fontRef idx="minor">
+            <a:schemeClr val="tx1"/>
+          </a:fontRef>
+        </p:style>
+      </p:cxnSp>
+      <p:cxnSp>
+        <p:nvCxnSpPr>
+          <p:cNvPr id="32" name="drawio-edge-58-segment-2"/>
+          <p:cNvCxnSpPr/>
+          <p:nvPr/>
+        </p:nvCxnSpPr>
+        <p:spPr>
+          <a:xfrm>
+            <a:off x="10329062" y="4456420"/>
+            <a:ext cx="731520" cy="0"/>
+          </a:xfrm>
+          <a:prstGeom prst="line">
+            <a:avLst/>
+          </a:prstGeom>
+          <a:ln w="11704">
+            <a:solidFill>
+              <a:srgbClr val="806491"/>
+            </a:solidFill>
+            <a:tailEnd type="triangle"/>
+          </a:ln>
+        </p:spPr>
+        <p:style>
+          <a:lnRef idx="2">
+            <a:schemeClr val="accent1"/>
+          </a:lnRef>
+          <a:fillRef idx="0">
+            <a:schemeClr val="accent1"/>
+          </a:fillRef>
+          <a:effectRef idx="1">
+            <a:schemeClr val="accent1"/>
+          </a:effectRef>
+          <a:fontRef idx="minor">
+            <a:schemeClr val="tx1"/>
+          </a:fontRef>
+        </p:style>
+      </p:cxnSp>
+      <p:cxnSp>
+        <p:nvCxnSpPr>
+          <p:cNvPr id="33" name="drawio-edge-59-segment-0"/>
+          <p:cNvCxnSpPr/>
+          <p:nvPr/>
+        </p:nvCxnSpPr>
+        <p:spPr>
+          <a:xfrm>
+            <a:off x="13577011" y="2691994"/>
+            <a:ext cx="292608" cy="731520"/>
+          </a:xfrm>
+          <a:prstGeom prst="line">
+            <a:avLst/>
+          </a:prstGeom>
+          <a:ln w="11704">
+            <a:solidFill>
+              <a:srgbClr val="4F7A54"/>
+            </a:solidFill>
+            <a:prstDash val="dash"/>
+          </a:ln>
+        </p:spPr>
+        <p:style>
+          <a:lnRef idx="2">
+            <a:schemeClr val="accent1"/>
+          </a:lnRef>
+          <a:fillRef idx="0">
+            <a:schemeClr val="accent1"/>
+          </a:fillRef>
+          <a:effectRef idx="1">
+            <a:schemeClr val="accent1"/>
+          </a:effectRef>
+          <a:fontRef idx="minor">
+            <a:schemeClr val="tx1"/>
+          </a:fontRef>
+        </p:style>
+      </p:cxnSp>
+      <p:cxnSp>
+        <p:nvCxnSpPr>
+          <p:cNvPr id="34" name="drawio-edge-59-segment-1"/>
+          <p:cNvCxnSpPr/>
+          <p:nvPr/>
+        </p:nvCxnSpPr>
+        <p:spPr>
+          <a:xfrm>
+            <a:off x="13869619" y="3423514"/>
+            <a:ext cx="0" cy="497433"/>
+          </a:xfrm>
+          <a:prstGeom prst="line">
+            <a:avLst/>
+          </a:prstGeom>
+          <a:ln w="11704">
+            <a:solidFill>
+              <a:srgbClr val="4F7A54"/>
+            </a:solidFill>
+            <a:prstDash val="dash"/>
+          </a:ln>
+        </p:spPr>
+        <p:style>
+          <a:lnRef idx="2">
+            <a:schemeClr val="accent1"/>
+          </a:lnRef>
+          <a:fillRef idx="0">
+            <a:schemeClr val="accent1"/>
+          </a:fillRef>
+          <a:effectRef idx="1">
+            <a:schemeClr val="accent1"/>
+          </a:effectRef>
+          <a:fontRef idx="minor">
+            <a:schemeClr val="tx1"/>
+          </a:fontRef>
+        </p:style>
+      </p:cxnSp>
+      <p:cxnSp>
+        <p:nvCxnSpPr>
+          <p:cNvPr id="35" name="drawio-edge-59-segment-2"/>
+          <p:cNvCxnSpPr/>
+          <p:nvPr/>
+        </p:nvCxnSpPr>
+        <p:spPr>
+          <a:xfrm flipH="1">
+            <a:off x="11996928" y="3920947"/>
+            <a:ext cx="1872691" cy="0"/>
+          </a:xfrm>
+          <a:prstGeom prst="line">
+            <a:avLst/>
+          </a:prstGeom>
+          <a:ln w="11704">
+            <a:solidFill>
+              <a:srgbClr val="4F7A54"/>
+            </a:solidFill>
+            <a:prstDash val="dash"/>
+          </a:ln>
+        </p:spPr>
+        <p:style>
+          <a:lnRef idx="2">
+            <a:schemeClr val="accent1"/>
+          </a:lnRef>
+          <a:fillRef idx="0">
+            <a:schemeClr val="accent1"/>
+          </a:fillRef>
+          <a:effectRef idx="1">
+            <a:schemeClr val="accent1"/>
+          </a:effectRef>
+          <a:fontRef idx="minor">
+            <a:schemeClr val="tx1"/>
+          </a:fontRef>
+        </p:style>
+      </p:cxnSp>
+      <p:cxnSp>
+        <p:nvCxnSpPr>
+          <p:cNvPr id="36" name="drawio-edge-59-segment-3"/>
+          <p:cNvCxnSpPr/>
+          <p:nvPr/>
+        </p:nvCxnSpPr>
+        <p:spPr>
+          <a:xfrm>
+            <a:off x="11996928" y="3920947"/>
+            <a:ext cx="0" cy="117043"/>
+          </a:xfrm>
+          <a:prstGeom prst="line">
+            <a:avLst/>
+          </a:prstGeom>
+          <a:ln w="11704">
+            <a:solidFill>
+              <a:srgbClr val="4F7A54"/>
+            </a:solidFill>
+            <a:prstDash val="dash"/>
+            <a:tailEnd type="triangle"/>
+          </a:ln>
+        </p:spPr>
+        <p:style>
+          <a:lnRef idx="2">
+            <a:schemeClr val="accent1"/>
+          </a:lnRef>
+          <a:fillRef idx="0">
+            <a:schemeClr val="accent1"/>
+          </a:fillRef>
+          <a:effectRef idx="1">
+            <a:schemeClr val="accent1"/>
+          </a:effectRef>
+          <a:fontRef idx="minor">
+            <a:schemeClr val="tx1"/>
+          </a:fontRef>
+        </p:style>
+      </p:cxnSp>
+      <p:sp>
+        <p:nvSpPr>
+          <p:cNvPr id="37" name="drawio-edge-label-59"/>
+          <p:cNvSpPr txBox="1"/>
+          <p:nvPr/>
+        </p:nvSpPr>
+        <p:spPr>
+          <a:xfrm>
+            <a:off x="13196621" y="3602004"/>
+            <a:ext cx="1345997" cy="140452"/>
+          </a:xfrm>
+          <a:prstGeom prst="rect">
+            <a:avLst/>
+          </a:prstGeom>
+          <a:solidFill>
+            <a:srgbClr val="FFFFFF"/>
+          </a:solidFill>
+        </p:spPr>
+        <p:txBody>
+          <a:bodyPr wrap="square" lIns="17556" rIns="17556" tIns="5852" bIns="5852" anchor="ctr">
+            <a:spAutoFit/>
+          </a:bodyPr>
+          <a:lstStyle/>
+          <a:p>
+            <a:pPr algn="ctr">
+              <a:spcBef>
+                <a:spcPts val="0"/>
+              </a:spcBef>
+              <a:spcAft>
+                <a:spcPts val="0"/>
+              </a:spcAft>
+            </a:pPr>
+            <a:r>
+              <a:rPr sz="645" b="0">
+                <a:solidFill>
+                  <a:srgbClr val="000000"/>
+                </a:solidFill>
+                <a:latin typeface="Arial"/>
+              </a:rPr>
+              <a:t>motion bands</a:t>
+            </a:r>
+          </a:p>
+        </p:txBody>
+      </p:sp>
+      <p:cxnSp>
+        <p:nvCxnSpPr>
+          <p:cNvPr id="38" name="drawio-edge-66-segment-0"/>
+          <p:cNvCxnSpPr/>
+          <p:nvPr/>
+        </p:nvCxnSpPr>
+        <p:spPr>
+          <a:xfrm>
+            <a:off x="1082650" y="1638605"/>
+            <a:ext cx="0" cy="877824"/>
+          </a:xfrm>
+          <a:prstGeom prst="line">
+            <a:avLst/>
+          </a:prstGeom>
+          <a:ln w="11704">
+            <a:solidFill>
+              <a:srgbClr val="806491"/>
+            </a:solidFill>
+          </a:ln>
+        </p:spPr>
+        <p:style>
+          <a:lnRef idx="2">
+            <a:schemeClr val="accent1"/>
+          </a:lnRef>
+          <a:fillRef idx="0">
+            <a:schemeClr val="accent1"/>
+          </a:fillRef>
+          <a:effectRef idx="1">
+            <a:schemeClr val="accent1"/>
+          </a:effectRef>
+          <a:fontRef idx="minor">
+            <a:schemeClr val="tx1"/>
+          </a:fontRef>
+        </p:style>
+      </p:cxnSp>
+      <p:cxnSp>
+        <p:nvCxnSpPr>
+          <p:cNvPr id="39" name="drawio-edge-66-segment-1"/>
+          <p:cNvCxnSpPr/>
+          <p:nvPr/>
+        </p:nvCxnSpPr>
+        <p:spPr>
+          <a:xfrm>
+            <a:off x="1082650" y="2516429"/>
+            <a:ext cx="965606" cy="0"/>
+          </a:xfrm>
+          <a:prstGeom prst="line">
+            <a:avLst/>
+          </a:prstGeom>
+          <a:ln w="11704">
+            <a:solidFill>
+              <a:srgbClr val="806491"/>
+            </a:solidFill>
+            <a:tailEnd type="triangle"/>
+          </a:ln>
+        </p:spPr>
+        <p:style>
+          <a:lnRef idx="2">
+            <a:schemeClr val="accent1"/>
+          </a:lnRef>
+          <a:fillRef idx="0">
+            <a:schemeClr val="accent1"/>
+          </a:fillRef>
+          <a:effectRef idx="1">
+            <a:schemeClr val="accent1"/>
+          </a:effectRef>
+          <a:fontRef idx="minor">
+            <a:schemeClr val="tx1"/>
+          </a:fontRef>
+        </p:style>
+      </p:cxnSp>
+      <p:cxnSp>
+        <p:nvCxnSpPr>
+          <p:cNvPr id="40" name="drawio-edge-67-segment-0"/>
+          <p:cNvCxnSpPr/>
+          <p:nvPr/>
+        </p:nvCxnSpPr>
+        <p:spPr>
+          <a:xfrm>
+            <a:off x="3511296" y="2809037"/>
+            <a:ext cx="0" cy="643737"/>
+          </a:xfrm>
+          <a:prstGeom prst="line">
+            <a:avLst/>
+          </a:prstGeom>
+          <a:ln w="11704">
+            <a:solidFill>
+              <a:srgbClr val="806491"/>
+            </a:solidFill>
+            <a:prstDash val="dash"/>
+          </a:ln>
+        </p:spPr>
+        <p:style>
+          <a:lnRef idx="2">
+            <a:schemeClr val="accent1"/>
+          </a:lnRef>
+          <a:fillRef idx="0">
+            <a:schemeClr val="accent1"/>
+          </a:fillRef>
+          <a:effectRef idx="1">
+            <a:schemeClr val="accent1"/>
+          </a:effectRef>
+          <a:fontRef idx="minor">
+            <a:schemeClr val="tx1"/>
+          </a:fontRef>
+        </p:style>
+      </p:cxnSp>
+      <p:cxnSp>
+        <p:nvCxnSpPr>
+          <p:cNvPr id="41" name="drawio-edge-67-segment-1"/>
+          <p:cNvCxnSpPr/>
+          <p:nvPr/>
+        </p:nvCxnSpPr>
+        <p:spPr>
+          <a:xfrm>
+            <a:off x="3511296" y="3452774"/>
+            <a:ext cx="7315200" cy="0"/>
+          </a:xfrm>
+          <a:prstGeom prst="line">
+            <a:avLst/>
+          </a:prstGeom>
+          <a:ln w="11704">
+            <a:solidFill>
+              <a:srgbClr val="806491"/>
+            </a:solidFill>
+            <a:prstDash val="dash"/>
+          </a:ln>
+        </p:spPr>
+        <p:style>
+          <a:lnRef idx="2">
+            <a:schemeClr val="accent1"/>
+          </a:lnRef>
+          <a:fillRef idx="0">
+            <a:schemeClr val="accent1"/>
+          </a:fillRef>
+          <a:effectRef idx="1">
+            <a:schemeClr val="accent1"/>
+          </a:effectRef>
+          <a:fontRef idx="minor">
+            <a:schemeClr val="tx1"/>
+          </a:fontRef>
+        </p:style>
+      </p:cxnSp>
+      <p:cxnSp>
+        <p:nvCxnSpPr>
+          <p:cNvPr id="42" name="drawio-edge-67-segment-2"/>
+          <p:cNvCxnSpPr/>
+          <p:nvPr/>
+        </p:nvCxnSpPr>
+        <p:spPr>
+          <a:xfrm>
+            <a:off x="10826496" y="3452774"/>
+            <a:ext cx="0" cy="746151"/>
+          </a:xfrm>
+          <a:prstGeom prst="line">
+            <a:avLst/>
+          </a:prstGeom>
+          <a:ln w="11704">
+            <a:solidFill>
+              <a:srgbClr val="806491"/>
+            </a:solidFill>
+            <a:prstDash val="dash"/>
+          </a:ln>
+        </p:spPr>
+        <p:style>
+          <a:lnRef idx="2">
+            <a:schemeClr val="accent1"/>
+          </a:lnRef>
+          <a:fillRef idx="0">
+            <a:schemeClr val="accent1"/>
+          </a:fillRef>
+          <a:effectRef idx="1">
+            <a:schemeClr val="accent1"/>
+          </a:effectRef>
+          <a:fontRef idx="minor">
+            <a:schemeClr val="tx1"/>
+          </a:fontRef>
+        </p:style>
+      </p:cxnSp>
+      <p:cxnSp>
+        <p:nvCxnSpPr>
+          <p:cNvPr id="43" name="drawio-edge-67-segment-3"/>
+          <p:cNvCxnSpPr/>
+          <p:nvPr/>
+        </p:nvCxnSpPr>
+        <p:spPr>
+          <a:xfrm>
+            <a:off x="10826496" y="4198925"/>
+            <a:ext cx="234086" cy="0"/>
+          </a:xfrm>
+          <a:prstGeom prst="line">
+            <a:avLst/>
+          </a:prstGeom>
+          <a:ln w="11704">
+            <a:solidFill>
+              <a:srgbClr val="806491"/>
+            </a:solidFill>
+            <a:prstDash val="dash"/>
+            <a:tailEnd type="triangle"/>
+          </a:ln>
+        </p:spPr>
+        <p:style>
+          <a:lnRef idx="2">
+            <a:schemeClr val="accent1"/>
+          </a:lnRef>
+          <a:fillRef idx="0">
+            <a:schemeClr val="accent1"/>
+          </a:fillRef>
+          <a:effectRef idx="1">
+            <a:schemeClr val="accent1"/>
+          </a:effectRef>
+          <a:fontRef idx="minor">
+            <a:schemeClr val="tx1"/>
+          </a:fontRef>
+        </p:style>
+      </p:cxnSp>
+      <p:sp>
+        <p:nvSpPr>
+          <p:cNvPr id="44" name="drawio-edge-label-67"/>
+          <p:cNvSpPr txBox="1"/>
+          <p:nvPr/>
+        </p:nvSpPr>
+        <p:spPr>
+          <a:xfrm>
+            <a:off x="6495898" y="3382548"/>
+            <a:ext cx="1345997" cy="140452"/>
+          </a:xfrm>
+          <a:prstGeom prst="rect">
+            <a:avLst/>
+          </a:prstGeom>
+          <a:solidFill>
+            <a:srgbClr val="FFFFFF"/>
+          </a:solidFill>
+        </p:spPr>
+        <p:txBody>
+          <a:bodyPr wrap="square" lIns="17556" rIns="17556" tIns="5852" bIns="5852" anchor="ctr">
+            <a:spAutoFit/>
+          </a:bodyPr>
+          <a:lstStyle/>
+          <a:p>
+            <a:pPr algn="ctr">
+              <a:spcBef>
+                <a:spcPts val="0"/>
+              </a:spcBef>
+              <a:spcAft>
+                <a:spcPts val="0"/>
+              </a:spcAft>
+            </a:pPr>
+            <a:r>
+              <a:rPr sz="599" b="0">
+                <a:solidFill>
+                  <a:srgbClr val="000000"/>
+                </a:solidFill>
+                <a:latin typeface="Arial"/>
+              </a:rPr>
+              <a:t>frozen group embedding</a:t>
+            </a:r>
+          </a:p>
+        </p:txBody>
+      </p:sp>
+      <p:cxnSp>
+        <p:nvCxnSpPr>
+          <p:cNvPr id="45" name="drawio-edge-68-segment-0"/>
+          <p:cNvCxnSpPr/>
+          <p:nvPr/>
+        </p:nvCxnSpPr>
+        <p:spPr>
+          <a:xfrm>
+            <a:off x="4681728" y="4623206"/>
+            <a:ext cx="0" cy="263348"/>
+          </a:xfrm>
+          <a:prstGeom prst="line">
+            <a:avLst/>
+          </a:prstGeom>
+          <a:ln w="11704">
+            <a:solidFill>
+              <a:srgbClr val="806491"/>
+            </a:solidFill>
+            <a:prstDash val="dash"/>
+          </a:ln>
+        </p:spPr>
+        <p:style>
+          <a:lnRef idx="2">
+            <a:schemeClr val="accent1"/>
+          </a:lnRef>
+          <a:fillRef idx="0">
+            <a:schemeClr val="accent1"/>
+          </a:fillRef>
+          <a:effectRef idx="1">
+            <a:schemeClr val="accent1"/>
+          </a:effectRef>
+          <a:fontRef idx="minor">
+            <a:schemeClr val="tx1"/>
+          </a:fontRef>
+        </p:style>
+      </p:cxnSp>
+      <p:cxnSp>
+        <p:nvCxnSpPr>
+          <p:cNvPr id="46" name="drawio-edge-68-segment-1"/>
+          <p:cNvCxnSpPr/>
+          <p:nvPr/>
+        </p:nvCxnSpPr>
+        <p:spPr>
+          <a:xfrm>
+            <a:off x="4681728" y="4886554"/>
+            <a:ext cx="6203290" cy="0"/>
+          </a:xfrm>
+          <a:prstGeom prst="line">
+            <a:avLst/>
+          </a:prstGeom>
+          <a:ln w="11704">
+            <a:solidFill>
+              <a:srgbClr val="806491"/>
+            </a:solidFill>
+            <a:prstDash val="dash"/>
+          </a:ln>
+        </p:spPr>
+        <p:style>
+          <a:lnRef idx="2">
+            <a:schemeClr val="accent1"/>
+          </a:lnRef>
+          <a:fillRef idx="0">
+            <a:schemeClr val="accent1"/>
+          </a:fillRef>
+          <a:effectRef idx="1">
+            <a:schemeClr val="accent1"/>
+          </a:effectRef>
+          <a:fontRef idx="minor">
+            <a:schemeClr val="tx1"/>
+          </a:fontRef>
+        </p:style>
+      </p:cxnSp>
+      <p:cxnSp>
+        <p:nvCxnSpPr>
+          <p:cNvPr id="47" name="drawio-edge-68-segment-2"/>
+          <p:cNvCxnSpPr/>
+          <p:nvPr/>
+        </p:nvCxnSpPr>
+        <p:spPr>
+          <a:xfrm flipV="1">
+            <a:off x="10885018" y="4585167"/>
+            <a:ext cx="0" cy="301387"/>
+          </a:xfrm>
+          <a:prstGeom prst="line">
+            <a:avLst/>
+          </a:prstGeom>
+          <a:ln w="11704">
+            <a:solidFill>
+              <a:srgbClr val="806491"/>
+            </a:solidFill>
+            <a:prstDash val="dash"/>
+          </a:ln>
+        </p:spPr>
+        <p:style>
+          <a:lnRef idx="2">
+            <a:schemeClr val="accent1"/>
+          </a:lnRef>
+          <a:fillRef idx="0">
+            <a:schemeClr val="accent1"/>
+          </a:fillRef>
+          <a:effectRef idx="1">
+            <a:schemeClr val="accent1"/>
+          </a:effectRef>
+          <a:fontRef idx="minor">
+            <a:schemeClr val="tx1"/>
+          </a:fontRef>
+        </p:style>
+      </p:cxnSp>
+      <p:cxnSp>
+        <p:nvCxnSpPr>
+          <p:cNvPr id="48" name="drawio-edge-68-segment-3"/>
+          <p:cNvCxnSpPr/>
+          <p:nvPr/>
+        </p:nvCxnSpPr>
+        <p:spPr>
+          <a:xfrm>
+            <a:off x="10885018" y="4585167"/>
+            <a:ext cx="175564" cy="0"/>
+          </a:xfrm>
+          <a:prstGeom prst="line">
+            <a:avLst/>
+          </a:prstGeom>
+          <a:ln w="11704">
+            <a:solidFill>
+              <a:srgbClr val="806491"/>
+            </a:solidFill>
+            <a:prstDash val="dash"/>
+            <a:tailEnd type="triangle"/>
+          </a:ln>
+        </p:spPr>
+        <p:style>
+          <a:lnRef idx="2">
+            <a:schemeClr val="accent1"/>
+          </a:lnRef>
+          <a:fillRef idx="0">
+            <a:schemeClr val="accent1"/>
+          </a:fillRef>
+          <a:effectRef idx="1">
+            <a:schemeClr val="accent1"/>
+          </a:effectRef>
+          <a:fontRef idx="minor">
+            <a:schemeClr val="tx1"/>
+          </a:fontRef>
+        </p:style>
+      </p:cxnSp>
+      <p:sp>
+        <p:nvSpPr>
+          <p:cNvPr id="49" name="drawio-edge-label-68"/>
+          <p:cNvSpPr txBox="1"/>
+          <p:nvPr/>
+        </p:nvSpPr>
+        <p:spPr>
+          <a:xfrm>
+            <a:off x="7110374" y="4816328"/>
+            <a:ext cx="1345997" cy="140452"/>
+          </a:xfrm>
+          <a:prstGeom prst="rect">
+            <a:avLst/>
+          </a:prstGeom>
+          <a:solidFill>
+            <a:srgbClr val="FFFFFF"/>
+          </a:solidFill>
+        </p:spPr>
+        <p:txBody>
+          <a:bodyPr wrap="square" lIns="17556" rIns="17556" tIns="5852" bIns="5852" anchor="ctr">
+            <a:spAutoFit/>
+          </a:bodyPr>
+          <a:lstStyle/>
+          <a:p>
+            <a:pPr algn="ctr">
+              <a:spcBef>
+                <a:spcPts val="0"/>
+              </a:spcBef>
+              <a:spcAft>
+                <a:spcPts val="0"/>
+              </a:spcAft>
+            </a:pPr>
+            <a:r>
+              <a:rPr sz="599" b="0">
+                <a:solidFill>
+                  <a:srgbClr val="000000"/>
+                </a:solidFill>
+                <a:latin typeface="Arial"/>
+              </a:rPr>
+              <a:t>global text embedding</a:t>
+            </a:r>
+          </a:p>
+        </p:txBody>
+      </p:sp>
+      <p:sp>
+        <p:nvSpPr>
+          <p:cNvPr id="50" name="drawio-node-2"/>
+          <p:cNvSpPr txBox="1"/>
+          <p:nvPr/>
+        </p:nvSpPr>
+        <p:spPr>
+          <a:xfrm>
+            <a:off x="2926080" y="117043"/>
+            <a:ext cx="8778240" cy="234086"/>
+          </a:xfrm>
+          <a:prstGeom prst="rect">
+            <a:avLst/>
+          </a:prstGeom>
+          <a:noFill/>
+        </p:spPr>
+        <p:txBody>
+          <a:bodyPr wrap="square" lIns="17556" rIns="17556" tIns="5852" bIns="5852" anchor="ctr">
+            <a:spAutoFit/>
+          </a:bodyPr>
+          <a:lstStyle/>
+          <a:p>
+            <a:pPr algn="ctr">
+              <a:spcBef>
+                <a:spcPts val="0"/>
+              </a:spcBef>
+              <a:spcAft>
+                <a:spcPts val="0"/>
+              </a:spcAft>
+            </a:pPr>
+            <a:r>
+              <a:rPr sz="1290" b="1">
+                <a:solidFill>
+                  <a:srgbClr val="17233C"/>
+                </a:solidFill>
+                <a:latin typeface="Arial"/>
+              </a:rPr>
+              <a:t>PhaseSet: streamed permutation-invariant group periodic tokens</a:t>
+            </a:r>
+          </a:p>
+        </p:txBody>
+      </p:sp>
+      <p:sp>
+        <p:nvSpPr>
+          <p:cNvPr id="51" name="drawio-node-10"/>
+          <p:cNvSpPr/>
+          <p:nvPr/>
+        </p:nvSpPr>
+        <p:spPr>
+          <a:xfrm>
+            <a:off x="468173" y="994867"/>
+            <a:ext cx="1228954" cy="643738"/>
+          </a:xfrm>
+          <a:prstGeom prst="roundRect">
+            <a:avLst>
+              <a:gd name="adj" fmla="val 8000"/>
+            </a:avLst>
+          </a:prstGeom>
+          <a:solidFill>
+            <a:srgbClr val="D5E8D4"/>
+          </a:solidFill>
+          <a:ln w="11704">
+            <a:solidFill>
+              <a:srgbClr val="82B366"/>
+            </a:solidFill>
+          </a:ln>
+        </p:spPr>
+        <p:style>
+          <a:lnRef idx="1">
+            <a:schemeClr val="accent1"/>
+          </a:lnRef>
+          <a:fillRef idx="3">
+            <a:schemeClr val="accent1"/>
+          </a:fillRef>
+          <a:effectRef idx="2">
+            <a:schemeClr val="accent1"/>
+          </a:effectRef>
+          <a:fontRef idx="minor">
+            <a:schemeClr val="lt1"/>
+          </a:fontRef>
+        </p:style>
+        <p:txBody>
+          <a:bodyPr rtlCol="0" anchor="ctr" wrap="square" lIns="17556" rIns="17556" tIns="5852" bIns="5852"/>
+          <a:lstStyle/>
+          <a:p>
+            <a:pPr algn="ctr">
+              <a:spcBef>
+                <a:spcPts val="0"/>
+              </a:spcBef>
+              <a:spcAft>
+                <a:spcPts val="0"/>
+              </a:spcAft>
+            </a:pPr>
+            <a:r>
+              <a:rPr sz="691" b="1">
+                <a:solidFill>
+                  <a:srgbClr val="000000"/>
+                </a:solidFill>
+                <a:latin typeface="Arial"/>
+              </a:rPr>
+              <a:t>Group skeletons</a:t>
+            </a:r>
+          </a:p>
+          <a:p>
+            <a:pPr algn="ctr">
+              <a:spcBef>
+                <a:spcPts val="0"/>
+              </a:spcBef>
+              <a:spcAft>
+                <a:spcPts val="0"/>
+              </a:spcAft>
+            </a:pPr>
+            <a:r>
+              <a:rPr sz="691" b="1">
+                <a:solidFill>
+                  <a:srgbClr val="000000"/>
+                </a:solidFill>
+                <a:latin typeface="Arial"/>
+              </a:rPr>
+              <a:t>(B,K,T,22,3)</a:t>
+            </a:r>
+          </a:p>
+          <a:p>
+            <a:pPr algn="ctr">
+              <a:spcBef>
+                <a:spcPts val="0"/>
+              </a:spcBef>
+              <a:spcAft>
+                <a:spcPts val="0"/>
+              </a:spcAft>
+            </a:pPr>
+            <a:r>
+              <a:rPr sz="691" b="1">
+                <a:solidFill>
+                  <a:srgbClr val="000000"/>
+                </a:solidFill>
+                <a:latin typeface="Arial"/>
+              </a:rPr>
+              <a:t>dynamic actor mask</a:t>
+            </a:r>
+          </a:p>
+        </p:txBody>
+      </p:sp>
+      <p:sp>
+        <p:nvSpPr>
+          <p:cNvPr id="52" name="drawio-node-11"/>
+          <p:cNvSpPr/>
+          <p:nvPr/>
+        </p:nvSpPr>
+        <p:spPr>
+          <a:xfrm>
+            <a:off x="2048256" y="994867"/>
+            <a:ext cx="1228954" cy="643738"/>
+          </a:xfrm>
+          <a:prstGeom prst="roundRect">
+            <a:avLst>
+              <a:gd name="adj" fmla="val 8000"/>
+            </a:avLst>
+          </a:prstGeom>
+          <a:solidFill>
+            <a:srgbClr val="DAE8FC"/>
+          </a:solidFill>
+          <a:ln w="11704">
+            <a:solidFill>
+              <a:srgbClr val="6C8EBF"/>
+            </a:solidFill>
+          </a:ln>
+        </p:spPr>
+        <p:style>
+          <a:lnRef idx="1">
+            <a:schemeClr val="accent1"/>
+          </a:lnRef>
+          <a:fillRef idx="3">
+            <a:schemeClr val="accent1"/>
+          </a:fillRef>
+          <a:effectRef idx="2">
+            <a:schemeClr val="accent1"/>
+          </a:effectRef>
+          <a:fontRef idx="minor">
+            <a:schemeClr val="lt1"/>
+          </a:fontRef>
+        </p:style>
+        <p:txBody>
+          <a:bodyPr rtlCol="0" anchor="ctr" wrap="square" lIns="17556" rIns="17556" tIns="5852" bIns="5852"/>
+          <a:lstStyle/>
+          <a:p>
+            <a:pPr algn="ctr">
+              <a:spcBef>
+                <a:spcPts val="0"/>
+              </a:spcBef>
+              <a:spcAft>
+                <a:spcPts val="0"/>
+              </a:spcAft>
+            </a:pPr>
+            <a:r>
+              <a:rPr sz="691" b="1">
+                <a:solidFill>
+                  <a:srgbClr val="000000"/>
+                </a:solidFill>
+                <a:latin typeface="Arial"/>
+              </a:rPr>
+              <a:t>Shared body-motion</a:t>
+            </a:r>
+          </a:p>
+          <a:p>
+            <a:pPr algn="ctr">
+              <a:spcBef>
+                <a:spcPts val="0"/>
+              </a:spcBef>
+              <a:spcAft>
+                <a:spcPts val="0"/>
+              </a:spcAft>
+            </a:pPr>
+            <a:r>
+              <a:rPr sz="691" b="1">
+                <a:solidFill>
+                  <a:srgbClr val="000000"/>
+                </a:solidFill>
+                <a:latin typeface="Arial"/>
+              </a:rPr>
+              <a:t>activity extraction</a:t>
+            </a:r>
+          </a:p>
+          <a:p>
+            <a:pPr algn="ctr">
+              <a:spcBef>
+                <a:spcPts val="0"/>
+              </a:spcBef>
+              <a:spcAft>
+                <a:spcPts val="0"/>
+              </a:spcAft>
+            </a:pPr>
+            <a:r>
+              <a:rPr sz="691" b="1">
+                <a:solidFill>
+                  <a:srgbClr val="000000"/>
+                </a:solidFill>
+                <a:latin typeface="Arial"/>
+              </a:rPr>
+              <a:t>fixed, mask-aware</a:t>
+            </a:r>
+          </a:p>
+        </p:txBody>
+      </p:sp>
+      <p:sp>
+        <p:nvSpPr>
+          <p:cNvPr id="53" name="drawio-node-12"/>
+          <p:cNvSpPr/>
+          <p:nvPr/>
+        </p:nvSpPr>
+        <p:spPr>
+          <a:xfrm>
+            <a:off x="3628339" y="994867"/>
+            <a:ext cx="1345997" cy="643738"/>
+          </a:xfrm>
+          <a:prstGeom prst="roundRect">
+            <a:avLst>
+              <a:gd name="adj" fmla="val 8000"/>
+            </a:avLst>
+          </a:prstGeom>
+          <a:solidFill>
+            <a:srgbClr val="DAE8FC"/>
+          </a:solidFill>
+          <a:ln w="11704">
+            <a:solidFill>
+              <a:srgbClr val="6C8EBF"/>
+            </a:solidFill>
+          </a:ln>
+        </p:spPr>
+        <p:style>
+          <a:lnRef idx="1">
+            <a:schemeClr val="accent1"/>
+          </a:lnRef>
+          <a:fillRef idx="3">
+            <a:schemeClr val="accent1"/>
+          </a:fillRef>
+          <a:effectRef idx="2">
+            <a:schemeClr val="accent1"/>
+          </a:effectRef>
+          <a:fontRef idx="minor">
+            <a:schemeClr val="lt1"/>
+          </a:fontRef>
+        </p:style>
+        <p:txBody>
+          <a:bodyPr rtlCol="0" anchor="ctr" wrap="square" lIns="17556" rIns="17556" tIns="5852" bIns="5852"/>
+          <a:lstStyle/>
+          <a:p>
+            <a:pPr algn="ctr">
+              <a:spcBef>
+                <a:spcPts val="0"/>
+              </a:spcBef>
+              <a:spcAft>
+                <a:spcPts val="0"/>
+              </a:spcAft>
+            </a:pPr>
+            <a:r>
+              <a:rPr sz="691" b="1">
+                <a:solidFill>
+                  <a:srgbClr val="000000"/>
+                </a:solidFill>
+                <a:latin typeface="Arial"/>
+              </a:rPr>
+              <a:t>Six fixed Morlet bands</a:t>
+            </a:r>
+          </a:p>
+          <a:p>
+            <a:pPr algn="ctr">
+              <a:spcBef>
+                <a:spcPts val="0"/>
+              </a:spcBef>
+              <a:spcAft>
+                <a:spcPts val="0"/>
+              </a:spcAft>
+            </a:pPr>
+            <a:r>
+              <a:rPr sz="691" b="1">
+                <a:solidFill>
+                  <a:srgbClr val="000000"/>
+                </a:solidFill>
+                <a:latin typeface="Arial"/>
+              </a:rPr>
+              <a:t>compute each actor once</a:t>
+            </a:r>
+          </a:p>
+        </p:txBody>
+      </p:sp>
+      <p:sp>
+        <p:nvSpPr>
+          <p:cNvPr id="54" name="drawio-node-13"/>
+          <p:cNvSpPr/>
+          <p:nvPr/>
+        </p:nvSpPr>
+        <p:spPr>
+          <a:xfrm>
+            <a:off x="5325466" y="994867"/>
+            <a:ext cx="1463040" cy="643738"/>
+          </a:xfrm>
+          <a:prstGeom prst="roundRect">
+            <a:avLst>
+              <a:gd name="adj" fmla="val 8000"/>
+            </a:avLst>
+          </a:prstGeom>
+          <a:solidFill>
+            <a:srgbClr val="FFF2CC"/>
+          </a:solidFill>
+          <a:ln w="11704">
+            <a:solidFill>
+              <a:srgbClr val="D6B656"/>
+            </a:solidFill>
+          </a:ln>
+        </p:spPr>
+        <p:style>
+          <a:lnRef idx="1">
+            <a:schemeClr val="accent1"/>
+          </a:lnRef>
+          <a:fillRef idx="3">
+            <a:schemeClr val="accent1"/>
+          </a:fillRef>
+          <a:effectRef idx="2">
+            <a:schemeClr val="accent1"/>
+          </a:effectRef>
+          <a:fontRef idx="minor">
+            <a:schemeClr val="lt1"/>
+          </a:fontRef>
+        </p:style>
+        <p:txBody>
+          <a:bodyPr rtlCol="0" anchor="ctr" wrap="square" lIns="17556" rIns="17556" tIns="5852" bIns="5852"/>
+          <a:lstStyle/>
+          <a:p>
+            <a:pPr algn="ctr">
+              <a:spcBef>
+                <a:spcPts val="0"/>
+              </a:spcBef>
+              <a:spcAft>
+                <a:spcPts val="0"/>
+              </a:spcAft>
+            </a:pPr>
+            <a:r>
+              <a:rPr sz="691" b="1">
+                <a:solidFill>
+                  <a:srgbClr val="000000"/>
+                </a:solidFill>
+                <a:latin typeface="Arial"/>
+              </a:rPr>
+              <a:t>Stream all unordered pairs</a:t>
+            </a:r>
+          </a:p>
+          <a:p>
+            <a:pPr algn="ctr">
+              <a:spcBef>
+                <a:spcPts val="0"/>
+              </a:spcBef>
+              <a:spcAft>
+                <a:spcPts val="0"/>
+              </a:spcAft>
+            </a:pPr>
+            <a:r>
+              <a:rPr sz="691" b="1">
+                <a:solidFill>
+                  <a:srgbClr val="000000"/>
+                </a:solidFill>
+                <a:latin typeface="Arial"/>
+              </a:rPr>
+              <a:t>canonical 64-edge blocks</a:t>
+            </a:r>
+          </a:p>
+          <a:p>
+            <a:pPr algn="ctr">
+              <a:spcBef>
+                <a:spcPts val="0"/>
+              </a:spcBef>
+              <a:spcAft>
+                <a:spcPts val="0"/>
+              </a:spcAft>
+            </a:pPr>
+            <a:r>
+              <a:rPr sz="691" b="1">
+                <a:solidFill>
+                  <a:srgbClr val="000000"/>
+                </a:solidFill>
+                <a:latin typeface="Arial"/>
+              </a:rPr>
+              <a:t>no dense K×K tensor</a:t>
+            </a:r>
+          </a:p>
+        </p:txBody>
+      </p:sp>
+      <p:sp>
+        <p:nvSpPr>
+          <p:cNvPr id="55" name="drawio-node-14"/>
+          <p:cNvSpPr/>
+          <p:nvPr/>
+        </p:nvSpPr>
+        <p:spPr>
+          <a:xfrm>
+            <a:off x="7139635" y="994867"/>
+            <a:ext cx="1228954" cy="643738"/>
+          </a:xfrm>
+          <a:prstGeom prst="roundRect">
+            <a:avLst>
+              <a:gd name="adj" fmla="val 8000"/>
+            </a:avLst>
+          </a:prstGeom>
+          <a:solidFill>
+            <a:srgbClr val="DAE8FC"/>
+          </a:solidFill>
+          <a:ln w="11704">
+            <a:solidFill>
+              <a:srgbClr val="6C8EBF"/>
+            </a:solidFill>
+          </a:ln>
+        </p:spPr>
+        <p:style>
+          <a:lnRef idx="1">
+            <a:schemeClr val="accent1"/>
+          </a:lnRef>
+          <a:fillRef idx="3">
+            <a:schemeClr val="accent1"/>
+          </a:fillRef>
+          <a:effectRef idx="2">
+            <a:schemeClr val="accent1"/>
+          </a:effectRef>
+          <a:fontRef idx="minor">
+            <a:schemeClr val="lt1"/>
+          </a:fontRef>
+        </p:style>
+        <p:txBody>
+          <a:bodyPr rtlCol="0" anchor="ctr" wrap="square" lIns="17556" rIns="17556" tIns="5852" bIns="5852"/>
+          <a:lstStyle/>
+          <a:p>
+            <a:pPr algn="ctr">
+              <a:spcBef>
+                <a:spcPts val="0"/>
+              </a:spcBef>
+              <a:spcAft>
+                <a:spcPts val="0"/>
+              </a:spcAft>
+            </a:pPr>
+            <a:r>
+              <a:rPr sz="691" b="0">
+                <a:solidFill>
+                  <a:srgbClr val="000000"/>
+                </a:solidFill>
+                <a:latin typeface="Arial"/>
+              </a:rPr>
+              <a:t>Directed 13D relations</a:t>
+            </a:r>
+          </a:p>
+          <a:p>
+            <a:pPr algn="ctr">
+              <a:spcBef>
+                <a:spcPts val="0"/>
+              </a:spcBef>
+              <a:spcAft>
+                <a:spcPts val="0"/>
+              </a:spcAft>
+            </a:pPr>
+            <a:r>
+              <a:rPr sz="691" b="0">
+                <a:solidFill>
+                  <a:srgbClr val="000000"/>
+                </a:solidFill>
+                <a:latin typeface="Arial"/>
+              </a:rPr>
+              <a:t>u</a:t>
+            </a:r>
+            <a:r>
+              <a:rPr sz="518" b="0" baseline="-25000">
+                <a:solidFill>
+                  <a:srgbClr val="000000"/>
+                </a:solidFill>
+                <a:latin typeface="Arial"/>
+              </a:rPr>
+              <a:t>ij</a:t>
+            </a:r>
+            <a:r>
+              <a:rPr sz="691" b="0">
+                <a:solidFill>
+                  <a:srgbClr val="000000"/>
+                </a:solidFill>
+                <a:latin typeface="Arial"/>
+              </a:rPr>
+              <a:t>, u</a:t>
+            </a:r>
+            <a:r>
+              <a:rPr sz="518" b="0" baseline="-25000">
+                <a:solidFill>
+                  <a:srgbClr val="000000"/>
+                </a:solidFill>
+                <a:latin typeface="Arial"/>
+              </a:rPr>
+              <a:t>ji</a:t>
+            </a:r>
+          </a:p>
+        </p:txBody>
+      </p:sp>
+      <p:sp>
+        <p:nvSpPr>
+          <p:cNvPr id="56" name="drawio-node-15"/>
+          <p:cNvSpPr/>
+          <p:nvPr/>
+        </p:nvSpPr>
+        <p:spPr>
+          <a:xfrm>
+            <a:off x="8719718" y="760781"/>
+            <a:ext cx="1345997" cy="585216"/>
+          </a:xfrm>
+          <a:prstGeom prst="roundRect">
+            <a:avLst>
+              <a:gd name="adj" fmla="val 8000"/>
+            </a:avLst>
+          </a:prstGeom>
+          <a:solidFill>
+            <a:srgbClr val="FFE6CC"/>
+          </a:solidFill>
+          <a:ln w="11704">
+            <a:solidFill>
+              <a:srgbClr val="D79B00"/>
+            </a:solidFill>
+          </a:ln>
+        </p:spPr>
+        <p:style>
+          <a:lnRef idx="1">
+            <a:schemeClr val="accent1"/>
+          </a:lnRef>
+          <a:fillRef idx="3">
+            <a:schemeClr val="accent1"/>
+          </a:fillRef>
+          <a:effectRef idx="2">
+            <a:schemeClr val="accent1"/>
+          </a:effectRef>
+          <a:fontRef idx="minor">
+            <a:schemeClr val="lt1"/>
+          </a:fontRef>
+        </p:style>
+        <p:txBody>
+          <a:bodyPr rtlCol="0" anchor="ctr" wrap="square" lIns="17556" rIns="17556" tIns="5852" bIns="5852"/>
+          <a:lstStyle/>
+          <a:p>
+            <a:pPr algn="ctr">
+              <a:spcBef>
+                <a:spcPts val="0"/>
+              </a:spcBef>
+              <a:spcAft>
+                <a:spcPts val="0"/>
+              </a:spcAft>
+            </a:pPr>
+            <a:r>
+              <a:rPr sz="691" b="1">
+                <a:solidFill>
+                  <a:srgbClr val="000000"/>
+                </a:solidFill>
+                <a:latin typeface="Arial"/>
+              </a:rPr>
+              <a:t>Symmetric PairMLP</a:t>
+            </a:r>
+          </a:p>
+          <a:p>
+            <a:pPr algn="ctr">
+              <a:spcBef>
+                <a:spcPts val="0"/>
+              </a:spcBef>
+              <a:spcAft>
+                <a:spcPts val="0"/>
+              </a:spcAft>
+            </a:pPr>
+            <a:r>
+              <a:rPr sz="691" b="1">
+                <a:solidFill>
+                  <a:srgbClr val="000000"/>
+                </a:solidFill>
+                <a:latin typeface="Arial"/>
+              </a:rPr>
+              <a:t>sum |diff| product</a:t>
+            </a:r>
+          </a:p>
+        </p:txBody>
+      </p:sp>
+      <p:sp>
+        <p:nvSpPr>
+          <p:cNvPr id="57" name="drawio-node-16"/>
+          <p:cNvSpPr/>
+          <p:nvPr/>
+        </p:nvSpPr>
+        <p:spPr>
+          <a:xfrm>
+            <a:off x="8719718" y="1697126"/>
+            <a:ext cx="1345997" cy="585216"/>
+          </a:xfrm>
+          <a:prstGeom prst="roundRect">
+            <a:avLst>
+              <a:gd name="adj" fmla="val 8000"/>
+            </a:avLst>
+          </a:prstGeom>
+          <a:solidFill>
+            <a:srgbClr val="E1D5E7"/>
+          </a:solidFill>
+          <a:ln w="11704">
+            <a:solidFill>
+              <a:srgbClr val="9673A6"/>
+            </a:solidFill>
+          </a:ln>
+        </p:spPr>
+        <p:style>
+          <a:lnRef idx="1">
+            <a:schemeClr val="accent1"/>
+          </a:lnRef>
+          <a:fillRef idx="3">
+            <a:schemeClr val="accent1"/>
+          </a:fillRef>
+          <a:effectRef idx="2">
+            <a:schemeClr val="accent1"/>
+          </a:effectRef>
+          <a:fontRef idx="minor">
+            <a:schemeClr val="lt1"/>
+          </a:fontRef>
+        </p:style>
+        <p:txBody>
+          <a:bodyPr rtlCol="0" anchor="ctr" wrap="square" lIns="17556" rIns="17556" tIns="5852" bIns="5852"/>
+          <a:lstStyle/>
+          <a:p>
+            <a:pPr algn="ctr">
+              <a:spcBef>
+                <a:spcPts val="0"/>
+              </a:spcBef>
+              <a:spcAft>
+                <a:spcPts val="0"/>
+              </a:spcAft>
+            </a:pPr>
+            <a:r>
+              <a:rPr sz="691" b="1">
+                <a:solidFill>
+                  <a:srgbClr val="000000"/>
+                </a:solidFill>
+                <a:latin typeface="Arial"/>
+              </a:rPr>
+              <a:t>Incident moments</a:t>
+            </a:r>
+          </a:p>
+          <a:p>
+            <a:pPr algn="ctr">
+              <a:spcBef>
+                <a:spcPts val="0"/>
+              </a:spcBef>
+              <a:spcAft>
+                <a:spcPts val="0"/>
+              </a:spcAft>
+            </a:pPr>
+            <a:r>
+              <a:rPr sz="691" b="1">
+                <a:solidFill>
+                  <a:srgbClr val="000000"/>
+                </a:solidFill>
+                <a:latin typeface="Arial"/>
+              </a:rPr>
+              <a:t>Δmean, M2, coverage, missing</a:t>
+            </a:r>
+          </a:p>
+        </p:txBody>
+      </p:sp>
+      <p:sp>
+        <p:nvSpPr>
+          <p:cNvPr id="58" name="drawio-node-17"/>
+          <p:cNvSpPr/>
+          <p:nvPr/>
+        </p:nvSpPr>
+        <p:spPr>
+          <a:xfrm>
+            <a:off x="10416845" y="760781"/>
+            <a:ext cx="1287475" cy="585216"/>
+          </a:xfrm>
+          <a:prstGeom prst="roundRect">
+            <a:avLst>
+              <a:gd name="adj" fmla="val 8000"/>
+            </a:avLst>
+          </a:prstGeom>
+          <a:solidFill>
+            <a:srgbClr val="FFE6CC"/>
+          </a:solidFill>
+          <a:ln w="11704">
+            <a:solidFill>
+              <a:srgbClr val="D79B00"/>
+            </a:solidFill>
+          </a:ln>
+        </p:spPr>
+        <p:style>
+          <a:lnRef idx="1">
+            <a:schemeClr val="accent1"/>
+          </a:lnRef>
+          <a:fillRef idx="3">
+            <a:schemeClr val="accent1"/>
+          </a:fillRef>
+          <a:effectRef idx="2">
+            <a:schemeClr val="accent1"/>
+          </a:effectRef>
+          <a:fontRef idx="minor">
+            <a:schemeClr val="lt1"/>
+          </a:fontRef>
+        </p:style>
+        <p:txBody>
+          <a:bodyPr rtlCol="0" anchor="ctr" wrap="square" lIns="17556" rIns="17556" tIns="5852" bIns="5852"/>
+          <a:lstStyle/>
+          <a:p>
+            <a:pPr algn="ctr">
+              <a:spcBef>
+                <a:spcPts val="0"/>
+              </a:spcBef>
+              <a:spcAft>
+                <a:spcPts val="0"/>
+              </a:spcAft>
+            </a:pPr>
+            <a:r>
+              <a:rPr sz="691" b="0">
+                <a:solidFill>
+                  <a:srgbClr val="000000"/>
+                </a:solidFill>
+                <a:latin typeface="Arial"/>
+              </a:rPr>
+              <a:t>Pair component</a:t>
+            </a:r>
+          </a:p>
+          <a:p>
+            <a:pPr algn="ctr">
+              <a:spcBef>
+                <a:spcPts val="0"/>
+              </a:spcBef>
+              <a:spcAft>
+                <a:spcPts val="0"/>
+              </a:spcAft>
+            </a:pPr>
+            <a:r>
+              <a:rPr sz="691" b="0">
+                <a:solidFill>
+                  <a:srgbClr val="000000"/>
+                </a:solidFill>
+                <a:latin typeface="Arial"/>
+              </a:rPr>
+              <a:t>canonical masked mean</a:t>
+            </a:r>
+          </a:p>
+        </p:txBody>
+      </p:sp>
+      <p:sp>
+        <p:nvSpPr>
+          <p:cNvPr id="59" name="drawio-node-18"/>
+          <p:cNvSpPr/>
+          <p:nvPr/>
+        </p:nvSpPr>
+        <p:spPr>
+          <a:xfrm>
+            <a:off x="10416845" y="1697126"/>
+            <a:ext cx="1404518" cy="585216"/>
+          </a:xfrm>
+          <a:prstGeom prst="roundRect">
+            <a:avLst>
+              <a:gd name="adj" fmla="val 8000"/>
+            </a:avLst>
+          </a:prstGeom>
+          <a:solidFill>
+            <a:srgbClr val="F8CECC"/>
+          </a:solidFill>
+          <a:ln w="11704">
+            <a:solidFill>
+              <a:srgbClr val="B85450"/>
+            </a:solidFill>
+          </a:ln>
+        </p:spPr>
+        <p:style>
+          <a:lnRef idx="1">
+            <a:schemeClr val="accent1"/>
+          </a:lnRef>
+          <a:fillRef idx="3">
+            <a:schemeClr val="accent1"/>
+          </a:fillRef>
+          <a:effectRef idx="2">
+            <a:schemeClr val="accent1"/>
+          </a:effectRef>
+          <a:fontRef idx="minor">
+            <a:schemeClr val="lt1"/>
+          </a:fontRef>
+        </p:style>
+        <p:txBody>
+          <a:bodyPr rtlCol="0" anchor="ctr" wrap="square" lIns="17556" rIns="17556" tIns="5852" bIns="5852"/>
+          <a:lstStyle/>
+          <a:p>
+            <a:pPr algn="ctr">
+              <a:spcBef>
+                <a:spcPts val="0"/>
+              </a:spcBef>
+              <a:spcAft>
+                <a:spcPts val="0"/>
+              </a:spcAft>
+            </a:pPr>
+            <a:r>
+              <a:rPr sz="691" b="0">
+                <a:solidFill>
+                  <a:srgbClr val="000000"/>
+                </a:solidFill>
+                <a:latin typeface="Arial"/>
+              </a:rPr>
+              <a:t>NodeMLP + hard gate</a:t>
+            </a:r>
+          </a:p>
+          <a:p>
+            <a:pPr algn="ctr">
+              <a:spcBef>
+                <a:spcPts val="0"/>
+              </a:spcBef>
+              <a:spcAft>
+                <a:spcPts val="0"/>
+              </a:spcAft>
+            </a:pPr>
+            <a:r>
+              <a:rPr sz="691" b="0">
+                <a:solidFill>
+                  <a:srgbClr val="000000"/>
+                </a:solidFill>
+                <a:latin typeface="Arial"/>
+              </a:rPr>
+              <a:t>K=2: exact +0 and zero grad</a:t>
+            </a:r>
+          </a:p>
+        </p:txBody>
+      </p:sp>
+      <p:sp>
+        <p:nvSpPr>
+          <p:cNvPr id="60" name="drawio-node-19"/>
+          <p:cNvSpPr/>
+          <p:nvPr/>
+        </p:nvSpPr>
+        <p:spPr>
+          <a:xfrm>
+            <a:off x="12172493" y="1111910"/>
+            <a:ext cx="1404518" cy="643738"/>
+          </a:xfrm>
+          <a:prstGeom prst="roundRect">
+            <a:avLst>
+              <a:gd name="adj" fmla="val 8000"/>
+            </a:avLst>
+          </a:prstGeom>
+          <a:solidFill>
+            <a:srgbClr val="FFE6CC"/>
+          </a:solidFill>
+          <a:ln w="11704">
+            <a:solidFill>
+              <a:srgbClr val="D79B00"/>
+            </a:solidFill>
+          </a:ln>
+        </p:spPr>
+        <p:style>
+          <a:lnRef idx="1">
+            <a:schemeClr val="accent1"/>
+          </a:lnRef>
+          <a:fillRef idx="3">
+            <a:schemeClr val="accent1"/>
+          </a:fillRef>
+          <a:effectRef idx="2">
+            <a:schemeClr val="accent1"/>
+          </a:effectRef>
+          <a:fontRef idx="minor">
+            <a:schemeClr val="lt1"/>
+          </a:fontRef>
+        </p:style>
+        <p:txBody>
+          <a:bodyPr rtlCol="0" anchor="ctr" wrap="square" lIns="17556" rIns="17556" tIns="5852" bIns="5852"/>
+          <a:lstStyle/>
+          <a:p>
+            <a:pPr algn="ctr">
+              <a:spcBef>
+                <a:spcPts val="0"/>
+              </a:spcBef>
+              <a:spcAft>
+                <a:spcPts val="0"/>
+              </a:spcAft>
+            </a:pPr>
+            <a:r>
+              <a:rPr sz="691" b="1">
+                <a:solidFill>
+                  <a:srgbClr val="000000"/>
+                </a:solidFill>
+                <a:latin typeface="Arial"/>
+              </a:rPr>
+              <a:t>CommonPostprocess</a:t>
+            </a:r>
+          </a:p>
+          <a:p>
+            <a:pPr algn="ctr">
+              <a:spcBef>
+                <a:spcPts val="0"/>
+              </a:spcBef>
+              <a:spcAft>
+                <a:spcPts val="0"/>
+              </a:spcAft>
+            </a:pPr>
+            <a:r>
+              <a:rPr sz="691" b="1">
+                <a:solidFill>
+                  <a:srgbClr val="000000"/>
+                </a:solidFill>
+                <a:latin typeface="Arial"/>
+              </a:rPr>
+              <a:t>pair + tanh(λ) · topology</a:t>
+            </a:r>
+          </a:p>
+        </p:txBody>
+      </p:sp>
+      <p:sp>
+        <p:nvSpPr>
+          <p:cNvPr id="61" name="drawio-node-20"/>
+          <p:cNvSpPr/>
+          <p:nvPr/>
+        </p:nvSpPr>
+        <p:spPr>
+          <a:xfrm>
+            <a:off x="12172493" y="2399386"/>
+            <a:ext cx="1404518" cy="585216"/>
+          </a:xfrm>
+          <a:prstGeom prst="roundRect">
+            <a:avLst>
+              <a:gd name="adj" fmla="val 8000"/>
+            </a:avLst>
+          </a:prstGeom>
+          <a:solidFill>
+            <a:srgbClr val="D5E8D4"/>
+          </a:solidFill>
+          <a:ln w="17556">
+            <a:solidFill>
+              <a:srgbClr val="82B366"/>
+            </a:solidFill>
+          </a:ln>
+        </p:spPr>
+        <p:style>
+          <a:lnRef idx="1">
+            <a:schemeClr val="accent1"/>
+          </a:lnRef>
+          <a:fillRef idx="3">
+            <a:schemeClr val="accent1"/>
+          </a:fillRef>
+          <a:effectRef idx="2">
+            <a:schemeClr val="accent1"/>
+          </a:effectRef>
+          <a:fontRef idx="minor">
+            <a:schemeClr val="lt1"/>
+          </a:fontRef>
+        </p:style>
+        <p:txBody>
+          <a:bodyPr rtlCol="0" anchor="ctr" wrap="square" lIns="17556" rIns="17556" tIns="5852" bIns="5852"/>
+          <a:lstStyle/>
+          <a:p>
+            <a:pPr algn="ctr">
+              <a:spcBef>
+                <a:spcPts val="0"/>
+              </a:spcBef>
+              <a:spcAft>
+                <a:spcPts val="0"/>
+              </a:spcAft>
+            </a:pPr>
+            <a:r>
+              <a:rPr sz="737" b="1">
+                <a:solidFill>
+                  <a:srgbClr val="000000"/>
+                </a:solidFill>
+                <a:latin typeface="Arial"/>
+              </a:rPr>
+              <a:t>Six group tokens</a:t>
+            </a:r>
+          </a:p>
+          <a:p>
+            <a:pPr algn="ctr">
+              <a:spcBef>
+                <a:spcPts val="0"/>
+              </a:spcBef>
+              <a:spcAft>
+                <a:spcPts val="0"/>
+              </a:spcAft>
+            </a:pPr>
+            <a:r>
+              <a:rPr sz="737" b="1">
+                <a:solidFill>
+                  <a:srgbClr val="000000"/>
+                </a:solidFill>
+                <a:latin typeface="Arial"/>
+              </a:rPr>
+              <a:t>(B,6,512)</a:t>
+            </a:r>
+          </a:p>
+        </p:txBody>
+      </p:sp>
+      <p:sp>
+        <p:nvSpPr>
+          <p:cNvPr id="62" name="drawio-node-21"/>
+          <p:cNvSpPr/>
+          <p:nvPr/>
+        </p:nvSpPr>
+        <p:spPr>
+          <a:xfrm>
+            <a:off x="5325466" y="2223821"/>
+            <a:ext cx="3043123" cy="585216"/>
+          </a:xfrm>
+          <a:prstGeom prst="roundRect">
+            <a:avLst>
+              <a:gd name="adj" fmla="val 8000"/>
+            </a:avLst>
+          </a:prstGeom>
+          <a:solidFill>
+            <a:srgbClr val="F5F5F5"/>
+          </a:solidFill>
+          <a:ln w="5852">
+            <a:solidFill>
+              <a:srgbClr val="666666"/>
+            </a:solidFill>
+            <a:prstDash val="dash"/>
+          </a:ln>
+        </p:spPr>
+        <p:style>
+          <a:lnRef idx="1">
+            <a:schemeClr val="accent1"/>
+          </a:lnRef>
+          <a:fillRef idx="3">
+            <a:schemeClr val="accent1"/>
+          </a:fillRef>
+          <a:effectRef idx="2">
+            <a:schemeClr val="accent1"/>
+          </a:effectRef>
+          <a:fontRef idx="minor">
+            <a:schemeClr val="lt1"/>
+          </a:fontRef>
+        </p:style>
+        <p:txBody>
+          <a:bodyPr rtlCol="0" anchor="ctr" wrap="square" lIns="17556" rIns="17556" tIns="5852" bIns="5852"/>
+          <a:lstStyle/>
+          <a:p>
+            <a:pPr algn="ctr">
+              <a:spcBef>
+                <a:spcPts val="0"/>
+              </a:spcBef>
+              <a:spcAft>
+                <a:spcPts val="0"/>
+              </a:spcAft>
+            </a:pPr>
+            <a:r>
+              <a:rPr sz="645" b="0">
+                <a:solidFill>
+                  <a:srgbClr val="000000"/>
+                </a:solidFill>
+                <a:latin typeface="Arial"/>
+              </a:rPr>
+              <a:t>Permutation invariant</a:t>
+            </a:r>
+          </a:p>
+          <a:p>
+            <a:pPr algn="ctr">
+              <a:spcBef>
+                <a:spcPts val="0"/>
+              </a:spcBef>
+              <a:spcAft>
+                <a:spcPts val="0"/>
+              </a:spcAft>
+            </a:pPr>
+            <a:r>
+              <a:rPr sz="645" b="0">
+                <a:solidFill>
+                  <a:srgbClr val="000000"/>
+                </a:solidFill>
+                <a:latin typeface="Arial"/>
+              </a:rPr>
+              <a:t>O(K²) streamed edges</a:t>
+            </a:r>
+          </a:p>
+          <a:p>
+            <a:pPr algn="ctr">
+              <a:spcBef>
+                <a:spcPts val="0"/>
+              </a:spcBef>
+              <a:spcAft>
+                <a:spcPts val="0"/>
+              </a:spcAft>
+            </a:pPr>
+            <a:r>
+              <a:rPr sz="645" b="0">
+                <a:solidFill>
+                  <a:srgbClr val="000000"/>
+                </a:solidFill>
+                <a:latin typeface="Arial"/>
+              </a:rPr>
+              <a:t>RESOURCE_LIMIT, never sampling</a:t>
+            </a:r>
+          </a:p>
+        </p:txBody>
+      </p:sp>
+      <p:sp>
+        <p:nvSpPr>
+          <p:cNvPr id="63" name="drawio-node-50"/>
+          <p:cNvSpPr/>
+          <p:nvPr/>
+        </p:nvSpPr>
+        <p:spPr>
+          <a:xfrm>
+            <a:off x="1989734" y="4096512"/>
+            <a:ext cx="1287475" cy="526694"/>
+          </a:xfrm>
+          <a:prstGeom prst="roundRect">
+            <a:avLst>
+              <a:gd name="adj" fmla="val 8000"/>
+            </a:avLst>
+          </a:prstGeom>
+          <a:solidFill>
+            <a:srgbClr val="D5E8D4"/>
+          </a:solidFill>
+          <a:ln w="11704">
+            <a:solidFill>
+              <a:srgbClr val="82B366"/>
+            </a:solidFill>
+          </a:ln>
+        </p:spPr>
+        <p:style>
+          <a:lnRef idx="1">
+            <a:schemeClr val="accent1"/>
+          </a:lnRef>
+          <a:fillRef idx="3">
+            <a:schemeClr val="accent1"/>
+          </a:fillRef>
+          <a:effectRef idx="2">
+            <a:schemeClr val="accent1"/>
+          </a:effectRef>
+          <a:fontRef idx="minor">
+            <a:schemeClr val="lt1"/>
+          </a:fontRef>
+        </p:style>
+        <p:txBody>
+          <a:bodyPr rtlCol="0" anchor="ctr" wrap="square" lIns="17556" rIns="17556" tIns="5852" bIns="5852"/>
+          <a:lstStyle/>
+          <a:p>
+            <a:pPr algn="ctr">
+              <a:spcBef>
+                <a:spcPts val="0"/>
+              </a:spcBef>
+              <a:spcAft>
+                <a:spcPts val="0"/>
+              </a:spcAft>
+            </a:pPr>
+            <a:r>
+              <a:rPr sz="737" b="1">
+                <a:solidFill>
+                  <a:srgbClr val="000000"/>
+                </a:solidFill>
+                <a:latin typeface="Arial"/>
+              </a:rPr>
+              <a:t>Human group text</a:t>
+            </a:r>
+          </a:p>
+        </p:txBody>
+      </p:sp>
+      <p:sp>
+        <p:nvSpPr>
+          <p:cNvPr id="64" name="drawio-node-51"/>
+          <p:cNvSpPr/>
+          <p:nvPr/>
+        </p:nvSpPr>
+        <p:spPr>
+          <a:xfrm>
+            <a:off x="4037990" y="4096512"/>
+            <a:ext cx="1287475" cy="526694"/>
+          </a:xfrm>
+          <a:prstGeom prst="roundRect">
+            <a:avLst>
+              <a:gd name="adj" fmla="val 8000"/>
+            </a:avLst>
+          </a:prstGeom>
+          <a:solidFill>
+            <a:srgbClr val="E1D5E7"/>
+          </a:solidFill>
+          <a:ln w="11704">
+            <a:solidFill>
+              <a:srgbClr val="9673A6"/>
+            </a:solidFill>
+          </a:ln>
+        </p:spPr>
+        <p:style>
+          <a:lnRef idx="1">
+            <a:schemeClr val="accent1"/>
+          </a:lnRef>
+          <a:fillRef idx="3">
+            <a:schemeClr val="accent1"/>
+          </a:fillRef>
+          <a:effectRef idx="2">
+            <a:schemeClr val="accent1"/>
+          </a:effectRef>
+          <a:fontRef idx="minor">
+            <a:schemeClr val="lt1"/>
+          </a:fontRef>
+        </p:style>
+        <p:txBody>
+          <a:bodyPr rtlCol="0" anchor="ctr" wrap="square" lIns="17556" rIns="17556" tIns="5852" bIns="5852"/>
+          <a:lstStyle/>
+          <a:p>
+            <a:pPr algn="ctr">
+              <a:spcBef>
+                <a:spcPts val="0"/>
+              </a:spcBef>
+              <a:spcAft>
+                <a:spcPts val="0"/>
+              </a:spcAft>
+            </a:pPr>
+            <a:r>
+              <a:rPr sz="737" b="0">
+                <a:solidFill>
+                  <a:srgbClr val="000000"/>
+                </a:solidFill>
+                <a:latin typeface="Arial"/>
+              </a:rPr>
+              <a:t>Frozen CLIP</a:t>
+            </a:r>
+          </a:p>
+          <a:p>
+            <a:pPr algn="ctr">
+              <a:spcBef>
+                <a:spcPts val="0"/>
+              </a:spcBef>
+              <a:spcAft>
+                <a:spcPts val="0"/>
+              </a:spcAft>
+            </a:pPr>
+            <a:r>
+              <a:rPr sz="737" b="0">
+                <a:solidFill>
+                  <a:srgbClr val="000000"/>
+                </a:solidFill>
+                <a:latin typeface="Arial"/>
+              </a:rPr>
+              <a:t>text tower</a:t>
+            </a:r>
+          </a:p>
+        </p:txBody>
+      </p:sp>
+      <p:sp>
+        <p:nvSpPr>
+          <p:cNvPr id="65" name="drawio-node-52"/>
+          <p:cNvSpPr/>
+          <p:nvPr/>
+        </p:nvSpPr>
+        <p:spPr>
+          <a:xfrm>
+            <a:off x="6086246" y="4096512"/>
+            <a:ext cx="1404518" cy="526694"/>
+          </a:xfrm>
+          <a:prstGeom prst="roundRect">
+            <a:avLst>
+              <a:gd name="adj" fmla="val 8000"/>
+            </a:avLst>
+          </a:prstGeom>
+          <a:solidFill>
+            <a:srgbClr val="FFE6CC"/>
+          </a:solidFill>
+          <a:ln w="11704">
+            <a:solidFill>
+              <a:srgbClr val="D79B00"/>
+            </a:solidFill>
+          </a:ln>
+        </p:spPr>
+        <p:style>
+          <a:lnRef idx="1">
+            <a:schemeClr val="accent1"/>
+          </a:lnRef>
+          <a:fillRef idx="3">
+            <a:schemeClr val="accent1"/>
+          </a:fillRef>
+          <a:effectRef idx="2">
+            <a:schemeClr val="accent1"/>
+          </a:effectRef>
+          <a:fontRef idx="minor">
+            <a:schemeClr val="lt1"/>
+          </a:fontRef>
+        </p:style>
+        <p:txBody>
+          <a:bodyPr rtlCol="0" anchor="ctr" wrap="square" lIns="17556" rIns="17556" tIns="5852" bIns="5852"/>
+          <a:lstStyle/>
+          <a:p>
+            <a:pPr algn="ctr">
+              <a:spcBef>
+                <a:spcPts val="0"/>
+              </a:spcBef>
+              <a:spcAft>
+                <a:spcPts val="0"/>
+              </a:spcAft>
+            </a:pPr>
+            <a:r>
+              <a:rPr sz="737" b="0">
+                <a:solidFill>
+                  <a:srgbClr val="000000"/>
+                </a:solidFill>
+                <a:latin typeface="Arial"/>
+              </a:rPr>
+              <a:t>Shared TextBandMLP</a:t>
+            </a:r>
+          </a:p>
+          <a:p>
+            <a:pPr algn="ctr">
+              <a:spcBef>
+                <a:spcPts val="0"/>
+              </a:spcBef>
+              <a:spcAft>
+                <a:spcPts val="0"/>
+              </a:spcAft>
+            </a:pPr>
+            <a:r>
+              <a:rPr sz="737" b="0">
+                <a:solidFill>
+                  <a:srgbClr val="000000"/>
+                </a:solidFill>
+                <a:latin typeface="Arial"/>
+              </a:rPr>
+              <a:t>+ learned band ID</a:t>
+            </a:r>
+          </a:p>
+        </p:txBody>
+      </p:sp>
+      <p:sp>
+        <p:nvSpPr>
+          <p:cNvPr id="66" name="drawio-node-53"/>
+          <p:cNvSpPr/>
+          <p:nvPr/>
+        </p:nvSpPr>
+        <p:spPr>
+          <a:xfrm>
+            <a:off x="8251546" y="4096512"/>
+            <a:ext cx="1345997" cy="526694"/>
+          </a:xfrm>
+          <a:prstGeom prst="roundRect">
+            <a:avLst>
+              <a:gd name="adj" fmla="val 8000"/>
+            </a:avLst>
+          </a:prstGeom>
+          <a:solidFill>
+            <a:srgbClr val="D5E8D4"/>
+          </a:solidFill>
+          <a:ln w="11704">
+            <a:solidFill>
+              <a:srgbClr val="82B366"/>
+            </a:solidFill>
+          </a:ln>
+        </p:spPr>
+        <p:style>
+          <a:lnRef idx="1">
+            <a:schemeClr val="accent1"/>
+          </a:lnRef>
+          <a:fillRef idx="3">
+            <a:schemeClr val="accent1"/>
+          </a:fillRef>
+          <a:effectRef idx="2">
+            <a:schemeClr val="accent1"/>
+          </a:effectRef>
+          <a:fontRef idx="minor">
+            <a:schemeClr val="lt1"/>
+          </a:fontRef>
+        </p:style>
+        <p:txBody>
+          <a:bodyPr rtlCol="0" anchor="ctr" wrap="square" lIns="17556" rIns="17556" tIns="5852" bIns="5852"/>
+          <a:lstStyle/>
+          <a:p>
+            <a:pPr algn="ctr">
+              <a:spcBef>
+                <a:spcPts val="0"/>
+              </a:spcBef>
+              <a:spcAft>
+                <a:spcPts val="0"/>
+              </a:spcAft>
+            </a:pPr>
+            <a:r>
+              <a:rPr sz="737" b="1">
+                <a:solidFill>
+                  <a:srgbClr val="000000"/>
+                </a:solidFill>
+                <a:latin typeface="Arial"/>
+              </a:rPr>
+              <a:t>Six semantic</a:t>
+            </a:r>
+          </a:p>
+          <a:p>
+            <a:pPr algn="ctr">
+              <a:spcBef>
+                <a:spcPts val="0"/>
+              </a:spcBef>
+              <a:spcAft>
+                <a:spcPts val="0"/>
+              </a:spcAft>
+            </a:pPr>
+            <a:r>
+              <a:rPr sz="737" b="1">
+                <a:solidFill>
+                  <a:srgbClr val="000000"/>
+                </a:solidFill>
+                <a:latin typeface="Arial"/>
+              </a:rPr>
+              <a:t>text-band tokens</a:t>
+            </a:r>
+          </a:p>
+        </p:txBody>
+      </p:sp>
+      <p:sp>
+        <p:nvSpPr>
+          <p:cNvPr id="67" name="drawio-node-54"/>
+          <p:cNvSpPr/>
+          <p:nvPr/>
+        </p:nvSpPr>
+        <p:spPr>
+          <a:xfrm>
+            <a:off x="11060582" y="4037990"/>
+            <a:ext cx="1872691" cy="643738"/>
+          </a:xfrm>
+          <a:prstGeom prst="roundRect">
+            <a:avLst>
+              <a:gd name="adj" fmla="val 8000"/>
+            </a:avLst>
+          </a:prstGeom>
+          <a:solidFill>
+            <a:srgbClr val="F8CECC"/>
+          </a:solidFill>
+          <a:ln w="17556">
+            <a:solidFill>
+              <a:srgbClr val="B85450"/>
+            </a:solidFill>
+          </a:ln>
+        </p:spPr>
+        <p:style>
+          <a:lnRef idx="1">
+            <a:schemeClr val="accent1"/>
+          </a:lnRef>
+          <a:fillRef idx="3">
+            <a:schemeClr val="accent1"/>
+          </a:fillRef>
+          <a:effectRef idx="2">
+            <a:schemeClr val="accent1"/>
+          </a:effectRef>
+          <a:fontRef idx="minor">
+            <a:schemeClr val="lt1"/>
+          </a:fontRef>
+        </p:style>
+        <p:txBody>
+          <a:bodyPr rtlCol="0" anchor="ctr" wrap="square" lIns="17556" rIns="17556" tIns="5852" bIns="5852"/>
+          <a:lstStyle/>
+          <a:p>
+            <a:pPr algn="ctr">
+              <a:spcBef>
+                <a:spcPts val="0"/>
+              </a:spcBef>
+              <a:spcAft>
+                <a:spcPts val="0"/>
+              </a:spcAft>
+            </a:pPr>
+            <a:r>
+              <a:rPr sz="737" b="1">
+                <a:solidFill>
+                  <a:srgbClr val="000000"/>
+                </a:solidFill>
+                <a:latin typeface="Arial"/>
+              </a:rPr>
+              <a:t>Frozen base score</a:t>
+            </a:r>
+          </a:p>
+          <a:p>
+            <a:pPr algn="ctr">
+              <a:spcBef>
+                <a:spcPts val="0"/>
+              </a:spcBef>
+              <a:spcAft>
+                <a:spcPts val="0"/>
+              </a:spcAft>
+            </a:pPr>
+            <a:r>
+              <a:rPr sz="737" b="1">
+                <a:solidFill>
+                  <a:srgbClr val="000000"/>
+                </a:solidFill>
+                <a:latin typeface="Arial"/>
+              </a:rPr>
+              <a:t>+ bounded mean band cosine</a:t>
+            </a:r>
+          </a:p>
+        </p:txBody>
+      </p:sp>
+      <p:sp>
+        <p:nvSpPr>
+          <p:cNvPr id="68" name="drawio-node-60"/>
+          <p:cNvSpPr/>
+          <p:nvPr/>
+        </p:nvSpPr>
+        <p:spPr>
+          <a:xfrm>
+            <a:off x="409651" y="5149901"/>
+            <a:ext cx="877824" cy="175565"/>
+          </a:xfrm>
+          <a:prstGeom prst="roundRect">
+            <a:avLst>
+              <a:gd name="adj" fmla="val 8000"/>
+            </a:avLst>
+          </a:prstGeom>
+          <a:solidFill>
+            <a:srgbClr val="D5E8D4"/>
+          </a:solidFill>
+          <a:ln w="5852">
+            <a:solidFill>
+              <a:srgbClr val="82B366"/>
+            </a:solidFill>
+          </a:ln>
+        </p:spPr>
+        <p:style>
+          <a:lnRef idx="1">
+            <a:schemeClr val="accent1"/>
+          </a:lnRef>
+          <a:fillRef idx="3">
+            <a:schemeClr val="accent1"/>
+          </a:fillRef>
+          <a:effectRef idx="2">
+            <a:schemeClr val="accent1"/>
+          </a:effectRef>
+          <a:fontRef idx="minor">
+            <a:schemeClr val="lt1"/>
+          </a:fontRef>
+        </p:style>
+        <p:txBody>
+          <a:bodyPr rtlCol="0" anchor="ctr" wrap="square" lIns="17556" rIns="17556" tIns="5852" bIns="5852"/>
+          <a:lstStyle/>
+          <a:p>
+            <a:pPr algn="ctr">
+              <a:spcBef>
+                <a:spcPts val="0"/>
+              </a:spcBef>
+              <a:spcAft>
+                <a:spcPts val="0"/>
+              </a:spcAft>
+            </a:pPr>
+            <a:r>
+              <a:rPr sz="599" b="0">
+                <a:solidFill>
+                  <a:srgbClr val="000000"/>
+                </a:solidFill>
+                <a:latin typeface="Arial"/>
+              </a:rPr>
+              <a:t>Input / output</a:t>
+            </a:r>
+          </a:p>
+        </p:txBody>
+      </p:sp>
+      <p:sp>
+        <p:nvSpPr>
+          <p:cNvPr id="69" name="drawio-node-61"/>
+          <p:cNvSpPr/>
+          <p:nvPr/>
+        </p:nvSpPr>
+        <p:spPr>
+          <a:xfrm>
+            <a:off x="1404518" y="5149901"/>
+            <a:ext cx="877824" cy="175565"/>
+          </a:xfrm>
+          <a:prstGeom prst="roundRect">
+            <a:avLst>
+              <a:gd name="adj" fmla="val 8000"/>
+            </a:avLst>
+          </a:prstGeom>
+          <a:solidFill>
+            <a:srgbClr val="DAE8FC"/>
+          </a:solidFill>
+          <a:ln w="5852">
+            <a:solidFill>
+              <a:srgbClr val="6C8EBF"/>
+            </a:solidFill>
+          </a:ln>
+        </p:spPr>
+        <p:style>
+          <a:lnRef idx="1">
+            <a:schemeClr val="accent1"/>
+          </a:lnRef>
+          <a:fillRef idx="3">
+            <a:schemeClr val="accent1"/>
+          </a:fillRef>
+          <a:effectRef idx="2">
+            <a:schemeClr val="accent1"/>
+          </a:effectRef>
+          <a:fontRef idx="minor">
+            <a:schemeClr val="lt1"/>
+          </a:fontRef>
+        </p:style>
+        <p:txBody>
+          <a:bodyPr rtlCol="0" anchor="ctr" wrap="square" lIns="17556" rIns="17556" tIns="5852" bIns="5852"/>
+          <a:lstStyle/>
+          <a:p>
+            <a:pPr algn="ctr">
+              <a:spcBef>
+                <a:spcPts val="0"/>
+              </a:spcBef>
+              <a:spcAft>
+                <a:spcPts val="0"/>
+              </a:spcAft>
+            </a:pPr>
+            <a:r>
+              <a:rPr sz="599" b="0">
+                <a:solidFill>
+                  <a:srgbClr val="000000"/>
+                </a:solidFill>
+                <a:latin typeface="Arial"/>
+              </a:rPr>
+              <a:t>Signal / relation</a:t>
+            </a:r>
+          </a:p>
+        </p:txBody>
+      </p:sp>
+      <p:sp>
+        <p:nvSpPr>
+          <p:cNvPr id="70" name="drawio-node-62"/>
+          <p:cNvSpPr/>
+          <p:nvPr/>
+        </p:nvSpPr>
+        <p:spPr>
+          <a:xfrm>
+            <a:off x="2399386" y="5149901"/>
+            <a:ext cx="994867" cy="175565"/>
+          </a:xfrm>
+          <a:prstGeom prst="roundRect">
+            <a:avLst>
+              <a:gd name="adj" fmla="val 8000"/>
+            </a:avLst>
+          </a:prstGeom>
+          <a:solidFill>
+            <a:srgbClr val="E1D5E7"/>
+          </a:solidFill>
+          <a:ln w="5852">
+            <a:solidFill>
+              <a:srgbClr val="9673A6"/>
+            </a:solidFill>
+          </a:ln>
+        </p:spPr>
+        <p:style>
+          <a:lnRef idx="1">
+            <a:schemeClr val="accent1"/>
+          </a:lnRef>
+          <a:fillRef idx="3">
+            <a:schemeClr val="accent1"/>
+          </a:fillRef>
+          <a:effectRef idx="2">
+            <a:schemeClr val="accent1"/>
+          </a:effectRef>
+          <a:fontRef idx="minor">
+            <a:schemeClr val="lt1"/>
+          </a:fontRef>
+        </p:style>
+        <p:txBody>
+          <a:bodyPr rtlCol="0" anchor="ctr" wrap="square" lIns="17556" rIns="17556" tIns="5852" bIns="5852"/>
+          <a:lstStyle/>
+          <a:p>
+            <a:pPr algn="ctr">
+              <a:spcBef>
+                <a:spcPts val="0"/>
+              </a:spcBef>
+              <a:spcAft>
+                <a:spcPts val="0"/>
+              </a:spcAft>
+            </a:pPr>
+            <a:r>
+              <a:rPr sz="599" b="0">
+                <a:solidFill>
+                  <a:srgbClr val="000000"/>
+                </a:solidFill>
+                <a:latin typeface="Arial"/>
+              </a:rPr>
+              <a:t>Attention / topology</a:t>
+            </a:r>
+          </a:p>
+        </p:txBody>
+      </p:sp>
+      <p:sp>
+        <p:nvSpPr>
+          <p:cNvPr id="71" name="drawio-node-63"/>
+          <p:cNvSpPr/>
+          <p:nvPr/>
+        </p:nvSpPr>
+        <p:spPr>
+          <a:xfrm>
+            <a:off x="3511296" y="5149901"/>
+            <a:ext cx="1053389" cy="175565"/>
+          </a:xfrm>
+          <a:prstGeom prst="roundRect">
+            <a:avLst>
+              <a:gd name="adj" fmla="val 8000"/>
+            </a:avLst>
+          </a:prstGeom>
+          <a:solidFill>
+            <a:srgbClr val="FFE6CC"/>
+          </a:solidFill>
+          <a:ln w="5852">
+            <a:solidFill>
+              <a:srgbClr val="D79B00"/>
+            </a:solidFill>
+          </a:ln>
+        </p:spPr>
+        <p:style>
+          <a:lnRef idx="1">
+            <a:schemeClr val="accent1"/>
+          </a:lnRef>
+          <a:fillRef idx="3">
+            <a:schemeClr val="accent1"/>
+          </a:fillRef>
+          <a:effectRef idx="2">
+            <a:schemeClr val="accent1"/>
+          </a:effectRef>
+          <a:fontRef idx="minor">
+            <a:schemeClr val="lt1"/>
+          </a:fontRef>
+        </p:style>
+        <p:txBody>
+          <a:bodyPr rtlCol="0" anchor="ctr" wrap="square" lIns="17556" rIns="17556" tIns="5852" bIns="5852"/>
+          <a:lstStyle/>
+          <a:p>
+            <a:pPr algn="ctr">
+              <a:spcBef>
+                <a:spcPts val="0"/>
+              </a:spcBef>
+              <a:spcAft>
+                <a:spcPts val="0"/>
+              </a:spcAft>
+            </a:pPr>
+            <a:r>
+              <a:rPr sz="599" b="0">
+                <a:solidFill>
+                  <a:srgbClr val="000000"/>
+                </a:solidFill>
+                <a:latin typeface="Arial"/>
+              </a:rPr>
+              <a:t>Projection / reduction</a:t>
+            </a:r>
+          </a:p>
+        </p:txBody>
+      </p:sp>
+      <p:sp>
+        <p:nvSpPr>
+          <p:cNvPr id="72" name="drawio-node-64"/>
+          <p:cNvSpPr/>
+          <p:nvPr/>
+        </p:nvSpPr>
+        <p:spPr>
+          <a:xfrm>
+            <a:off x="4681728" y="5149901"/>
+            <a:ext cx="819302" cy="175565"/>
+          </a:xfrm>
+          <a:prstGeom prst="roundRect">
+            <a:avLst>
+              <a:gd name="adj" fmla="val 8000"/>
+            </a:avLst>
+          </a:prstGeom>
+          <a:solidFill>
+            <a:srgbClr val="F8CECC"/>
+          </a:solidFill>
+          <a:ln w="5852">
+            <a:solidFill>
+              <a:srgbClr val="B85450"/>
+            </a:solidFill>
+          </a:ln>
+        </p:spPr>
+        <p:style>
+          <a:lnRef idx="1">
+            <a:schemeClr val="accent1"/>
+          </a:lnRef>
+          <a:fillRef idx="3">
+            <a:schemeClr val="accent1"/>
+          </a:fillRef>
+          <a:effectRef idx="2">
+            <a:schemeClr val="accent1"/>
+          </a:effectRef>
+          <a:fontRef idx="minor">
+            <a:schemeClr val="lt1"/>
+          </a:fontRef>
+        </p:style>
+        <p:txBody>
+          <a:bodyPr rtlCol="0" anchor="ctr" wrap="square" lIns="17556" rIns="17556" tIns="5852" bIns="5852"/>
+          <a:lstStyle/>
+          <a:p>
+            <a:pPr algn="ctr">
+              <a:spcBef>
+                <a:spcPts val="0"/>
+              </a:spcBef>
+              <a:spcAft>
+                <a:spcPts val="0"/>
+              </a:spcAft>
+            </a:pPr>
+            <a:r>
+              <a:rPr sz="599" b="0">
+                <a:solidFill>
+                  <a:srgbClr val="000000"/>
+                </a:solidFill>
+                <a:latin typeface="Arial"/>
+              </a:rPr>
+              <a:t>Gate / score</a:t>
+            </a:r>
+          </a:p>
+        </p:txBody>
+      </p:sp>
+      <p:sp>
+        <p:nvSpPr>
+          <p:cNvPr id="73" name="drawio-node-65"/>
+          <p:cNvSpPr/>
+          <p:nvPr/>
+        </p:nvSpPr>
+        <p:spPr>
+          <a:xfrm>
+            <a:off x="2048256" y="2223821"/>
+            <a:ext cx="2926080" cy="585216"/>
+          </a:xfrm>
+          <a:prstGeom prst="roundRect">
+            <a:avLst>
+              <a:gd name="adj" fmla="val 8000"/>
+            </a:avLst>
+          </a:prstGeom>
+          <a:solidFill>
+            <a:srgbClr val="E1D5E7"/>
+          </a:solidFill>
+          <a:ln w="11704">
+            <a:solidFill>
+              <a:srgbClr val="9673A6"/>
+            </a:solidFill>
+          </a:ln>
+        </p:spPr>
+        <p:style>
+          <a:lnRef idx="1">
+            <a:schemeClr val="accent1"/>
+          </a:lnRef>
+          <a:fillRef idx="3">
+            <a:schemeClr val="accent1"/>
+          </a:fillRef>
+          <a:effectRef idx="2">
+            <a:schemeClr val="accent1"/>
+          </a:effectRef>
+          <a:fontRef idx="minor">
+            <a:schemeClr val="lt1"/>
+          </a:fontRef>
+        </p:style>
+        <p:txBody>
+          <a:bodyPr rtlCol="0" anchor="ctr" wrap="square" lIns="17556" rIns="17556" tIns="5852" bIns="5852"/>
+          <a:lstStyle/>
+          <a:p>
+            <a:pPr algn="ctr">
+              <a:spcBef>
+                <a:spcPts val="0"/>
+              </a:spcBef>
+              <a:spcAft>
+                <a:spcPts val="0"/>
+              </a:spcAft>
+            </a:pPr>
+            <a:r>
+              <a:rPr sz="691" b="1">
+                <a:solidFill>
+                  <a:srgbClr val="000000"/>
+                </a:solidFill>
+                <a:latin typeface="Arial"/>
+              </a:rPr>
+              <a:t>Qualified B0 / B1 / B2 base</a:t>
+            </a:r>
+          </a:p>
+          <a:p>
+            <a:pPr algn="ctr">
+              <a:spcBef>
+                <a:spcPts val="0"/>
+              </a:spcBef>
+              <a:spcAft>
+                <a:spcPts val="0"/>
+              </a:spcAft>
+            </a:pPr>
+            <a:r>
+              <a:rPr sz="691" b="1">
+                <a:solidFill>
+                  <a:srgbClr val="000000"/>
+                </a:solidFill>
+                <a:latin typeface="Arial"/>
+              </a:rPr>
+              <a:t>shared actor encoding + group pooling</a:t>
+            </a:r>
+          </a:p>
+          <a:p>
+            <a:pPr algn="ctr">
+              <a:spcBef>
+                <a:spcPts val="0"/>
+              </a:spcBef>
+              <a:spcAft>
+                <a:spcPts val="0"/>
+              </a:spcAft>
+            </a:pPr>
+            <a:r>
+              <a:rPr sz="691" b="1">
+                <a:solidFill>
+                  <a:srgbClr val="000000"/>
+                </a:solidFill>
+                <a:latin typeface="Arial"/>
+              </a:rPr>
+              <a:t>frozen per seed for residual systems</a:t>
+            </a:r>
+          </a:p>
+        </p:txBody>
+      </p:sp>
     </p:spTree>
   </p:cSld>
   <p:clrMapOvr>

</xml_diff>